<commit_message>
Examen Parcial 1: guion, plan 20min, defensa de codigo y embeddings versionados
</commit_message>
<xml_diff>
--- a/slides/pptx/defensa_winoground.pptx
+++ b/slides/pptx/defensa_winoground.pptx
@@ -13,6 +13,27 @@
     <p:sldId id="261" r:id="rId12"/>
     <p:sldId id="262" r:id="rId13"/>
     <p:sldId id="263" r:id="rId14"/>
+    <p:sldId id="264" r:id="rId15"/>
+    <p:sldId id="265" r:id="rId16"/>
+    <p:sldId id="266" r:id="rId17"/>
+    <p:sldId id="267" r:id="rId18"/>
+    <p:sldId id="268" r:id="rId19"/>
+    <p:sldId id="269" r:id="rId20"/>
+    <p:sldId id="270" r:id="rId21"/>
+    <p:sldId id="271" r:id="rId22"/>
+    <p:sldId id="272" r:id="rId23"/>
+    <p:sldId id="273" r:id="rId24"/>
+    <p:sldId id="274" r:id="rId25"/>
+    <p:sldId id="275" r:id="rId26"/>
+    <p:sldId id="276" r:id="rId27"/>
+    <p:sldId id="277" r:id="rId28"/>
+    <p:sldId id="278" r:id="rId29"/>
+    <p:sldId id="279" r:id="rId30"/>
+    <p:sldId id="280" r:id="rId31"/>
+    <p:sldId id="281" r:id="rId32"/>
+    <p:sldId id="282" r:id="rId33"/>
+    <p:sldId id="283" r:id="rId34"/>
+    <p:sldId id="284" r:id="rId35"/>
   </p:sldIdLst>
   <p:sldSz cx="12191695" cy="6858000" type="screen4x3"/>
   <p:notesSz cx="6858000" cy="9144000"/>
@@ -3103,8 +3124,8 @@
         </p:nvSpPr>
         <p:spPr>
           <a:xfrm>
-            <a:off x="731520" y="2194560"/>
-            <a:ext cx="10698480" cy="2286000"/>
+            <a:off x="731520" y="2011680"/>
+            <a:ext cx="10698480" cy="2743200"/>
           </a:xfrm>
           <a:prstGeom prst="rect">
             <a:avLst/>
@@ -3118,7 +3139,7 @@
           <a:lstStyle/>
           <a:p>
             <a:pPr>
-              <a:defRPr sz="4400" b="1">
+              <a:defRPr sz="4000" b="1">
                 <a:solidFill>
                   <a:srgbClr val="0072B2"/>
                 </a:solidFill>
@@ -3130,19 +3151,19 @@
           </a:p>
           <a:p>
             <a:pPr>
-              <a:defRPr sz="2000">
-                <a:solidFill>
-                  <a:srgbClr val="333333"/>
-                </a:solidFill>
-              </a:defRPr>
-            </a:pPr>
-            <a:r>
-              <a:t>Retrieval alto ≠ razonamiento composicional</a:t>
-            </a:r>
-          </a:p>
-          <a:p>
-            <a:pPr>
-              <a:defRPr sz="2000">
+              <a:defRPr sz="1800">
+                <a:solidFill>
+                  <a:srgbClr val="333333"/>
+                </a:solidFill>
+              </a:defRPr>
+            </a:pPr>
+            <a:r>
+              <a:t>El retrieval alto no implica razonamiento composicional</a:t>
+            </a:r>
+          </a:p>
+          <a:p>
+            <a:pPr>
+              <a:defRPr sz="1800">
                 <a:solidFill>
                   <a:srgbClr val="333333"/>
                 </a:solidFill>
@@ -3154,7 +3175,7 @@
           </a:p>
           <a:p>
             <a:pPr>
-              <a:defRPr sz="2000">
+              <a:defRPr sz="1800">
                 <a:solidFill>
                   <a:srgbClr val="333333"/>
                 </a:solidFill>
@@ -3162,6 +3183,1314 @@
             </a:pPr>
             <a:r>
               <a:t>Cuadernos C5 · C8 · C10</a:t>
+            </a:r>
+          </a:p>
+        </p:txBody>
+      </p:sp>
+    </p:spTree>
+  </p:cSld>
+  <p:clrMapOvr>
+    <a:masterClrMapping/>
+  </p:clrMapOvr>
+</p:sld>
+</file>
+
+<file path=ppt/slides/slide10.xml><?xml version="1.0" encoding="utf-8"?>
+<p:sld xmlns:a="http://schemas.openxmlformats.org/drawingml/2006/main" xmlns:p="http://schemas.openxmlformats.org/presentationml/2006/main" xmlns:r="http://schemas.openxmlformats.org/officeDocument/2006/relationships">
+  <p:cSld>
+    <p:spTree>
+      <p:nvGrpSpPr>
+        <p:cNvPr id="1" name=""/>
+        <p:cNvGrpSpPr/>
+        <p:nvPr/>
+      </p:nvGrpSpPr>
+      <p:grpSpPr/>
+      <p:sp>
+        <p:nvSpPr>
+          <p:cNvPr id="2" name="TextBox 1"/>
+          <p:cNvSpPr txBox="1"/>
+          <p:nvPr/>
+        </p:nvSpPr>
+        <p:spPr>
+          <a:xfrm>
+            <a:off x="457200" y="274320"/>
+            <a:ext cx="11247120" cy="914400"/>
+          </a:xfrm>
+          <a:prstGeom prst="rect">
+            <a:avLst/>
+          </a:prstGeom>
+          <a:noFill/>
+        </p:spPr>
+        <p:txBody>
+          <a:bodyPr wrap="square">
+            <a:spAutoFit/>
+          </a:bodyPr>
+          <a:lstStyle/>
+          <a:p>
+            <a:pPr>
+              <a:defRPr sz="2800" b="1">
+                <a:solidFill>
+                  <a:srgbClr val="0072B2"/>
+                </a:solidFill>
+              </a:defRPr>
+            </a:pPr>
+            <a:r>
+              <a:t>Cómo funciona CLIP: un dual-encoder contrastivo</a:t>
+            </a:r>
+          </a:p>
+        </p:txBody>
+      </p:sp>
+      <p:sp>
+        <p:nvSpPr>
+          <p:cNvPr id="3" name="TextBox 2"/>
+          <p:cNvSpPr txBox="1"/>
+          <p:nvPr/>
+        </p:nvSpPr>
+        <p:spPr>
+          <a:xfrm>
+            <a:off x="548640" y="1280160"/>
+            <a:ext cx="11064240" cy="5120640"/>
+          </a:xfrm>
+          <a:prstGeom prst="rect">
+            <a:avLst/>
+          </a:prstGeom>
+          <a:noFill/>
+        </p:spPr>
+        <p:txBody>
+          <a:bodyPr wrap="square">
+            <a:spAutoFit/>
+          </a:bodyPr>
+          <a:lstStyle/>
+          <a:p>
+            <a:pPr>
+              <a:spcAft>
+                <a:spcPts val="700"/>
+              </a:spcAft>
+              <a:defRPr sz="1800">
+                <a:solidFill>
+                  <a:srgbClr val="333333"/>
+                </a:solidFill>
+              </a:defRPr>
+            </a:pPr>
+            <a:r>
+              <a:t>•  Dos torres separadas: una codifica la imagen, otra el texto.</a:t>
+            </a:r>
+          </a:p>
+          <a:p>
+            <a:pPr>
+              <a:spcAft>
+                <a:spcPts val="700"/>
+              </a:spcAft>
+              <a:defRPr sz="1800">
+                <a:solidFill>
+                  <a:srgbClr val="333333"/>
+                </a:solidFill>
+              </a:defRPr>
+            </a:pPr>
+            <a:r>
+              <a:t>•  Cada modalidad colapsa en un único vector global; se comparan por coseno.</a:t>
+            </a:r>
+          </a:p>
+          <a:p>
+            <a:pPr>
+              <a:spcAft>
+                <a:spcPts val="700"/>
+              </a:spcAft>
+              <a:defRPr sz="1800">
+                <a:solidFill>
+                  <a:srgbClr val="333333"/>
+                </a:solidFill>
+              </a:defRPr>
+            </a:pPr>
+            <a:r>
+              <a:t>•  Entrenado con aprendizaje contrastivo (acerca pares correctos, aleja incorrectos).</a:t>
+            </a:r>
+          </a:p>
+          <a:p>
+            <a:pPr>
+              <a:spcAft>
+                <a:spcPts val="700"/>
+              </a:spcAft>
+              <a:defRPr sz="1800">
+                <a:solidFill>
+                  <a:srgbClr val="333333"/>
+                </a:solidFill>
+              </a:defRPr>
+            </a:pPr>
+            <a:r>
+              <a:t>•  Es el motor del Cuaderno 10 (OpenCLIP): create_model_and_transforms, encode_*. Lo reutilicé tal cual.</a:t>
+            </a:r>
+          </a:p>
+        </p:txBody>
+      </p:sp>
+    </p:spTree>
+  </p:cSld>
+  <p:clrMapOvr>
+    <a:masterClrMapping/>
+  </p:clrMapOvr>
+</p:sld>
+</file>
+
+<file path=ppt/slides/slide11.xml><?xml version="1.0" encoding="utf-8"?>
+<p:sld xmlns:a="http://schemas.openxmlformats.org/drawingml/2006/main" xmlns:p="http://schemas.openxmlformats.org/presentationml/2006/main" xmlns:r="http://schemas.openxmlformats.org/officeDocument/2006/relationships">
+  <p:cSld>
+    <p:spTree>
+      <p:nvGrpSpPr>
+        <p:cNvPr id="1" name=""/>
+        <p:cNvGrpSpPr/>
+        <p:nvPr/>
+      </p:nvGrpSpPr>
+      <p:grpSpPr/>
+      <p:sp>
+        <p:nvSpPr>
+          <p:cNvPr id="2" name="TextBox 1"/>
+          <p:cNvSpPr txBox="1"/>
+          <p:nvPr/>
+        </p:nvSpPr>
+        <p:spPr>
+          <a:xfrm>
+            <a:off x="457200" y="274320"/>
+            <a:ext cx="11247120" cy="914400"/>
+          </a:xfrm>
+          <a:prstGeom prst="rect">
+            <a:avLst/>
+          </a:prstGeom>
+          <a:noFill/>
+        </p:spPr>
+        <p:txBody>
+          <a:bodyPr wrap="square">
+            <a:spAutoFit/>
+          </a:bodyPr>
+          <a:lstStyle/>
+          <a:p>
+            <a:pPr>
+              <a:defRPr sz="2800" b="1">
+                <a:solidFill>
+                  <a:srgbClr val="0072B2"/>
+                </a:solidFill>
+              </a:defRPr>
+            </a:pPr>
+            <a:r>
+              <a:t>Por qué un dual-encoder falla la composición</a:t>
+            </a:r>
+          </a:p>
+        </p:txBody>
+      </p:sp>
+      <p:sp>
+        <p:nvSpPr>
+          <p:cNvPr id="3" name="TextBox 2"/>
+          <p:cNvSpPr txBox="1"/>
+          <p:nvPr/>
+        </p:nvSpPr>
+        <p:spPr>
+          <a:xfrm>
+            <a:off x="548640" y="1280160"/>
+            <a:ext cx="11064240" cy="5120640"/>
+          </a:xfrm>
+          <a:prstGeom prst="rect">
+            <a:avLst/>
+          </a:prstGeom>
+          <a:noFill/>
+        </p:spPr>
+        <p:txBody>
+          <a:bodyPr wrap="square">
+            <a:spAutoFit/>
+          </a:bodyPr>
+          <a:lstStyle/>
+          <a:p>
+            <a:pPr>
+              <a:spcAft>
+                <a:spcPts val="700"/>
+              </a:spcAft>
+              <a:defRPr sz="1800">
+                <a:solidFill>
+                  <a:srgbClr val="333333"/>
+                </a:solidFill>
+              </a:defRPr>
+            </a:pPr>
+            <a:r>
+              <a:t>•  Un vector global se comporta como 'bolsa de conceptos'.</a:t>
+            </a:r>
+          </a:p>
+          <a:p>
+            <a:pPr>
+              <a:spcAft>
+                <a:spcPts val="700"/>
+              </a:spcAft>
+              <a:defRPr sz="1800">
+                <a:solidFill>
+                  <a:srgbClr val="333333"/>
+                </a:solidFill>
+              </a:defRPr>
+            </a:pPr>
+            <a:r>
+              <a:t>•  'old', 'young', 'kiss' activan dimensiones parecidas estén como estén compuestos.</a:t>
+            </a:r>
+          </a:p>
+          <a:p>
+            <a:pPr>
+              <a:spcAft>
+                <a:spcPts val="700"/>
+              </a:spcAft>
+              <a:defRPr sz="1800">
+                <a:solidFill>
+                  <a:srgbClr val="333333"/>
+                </a:solidFill>
+              </a:defRPr>
+            </a:pPr>
+            <a:r>
+              <a:t>•  No hay interacción token-a-token entre palabras y regiones.</a:t>
+            </a:r>
+          </a:p>
+          <a:p>
+            <a:pPr>
+              <a:spcAft>
+                <a:spcPts val="700"/>
+              </a:spcAft>
+              <a:defRPr sz="1800">
+                <a:solidFill>
+                  <a:srgbClr val="333333"/>
+                </a:solidFill>
+              </a:defRPr>
+            </a:pPr>
+            <a:r>
+              <a:t>•  Conexión C5/C8: la fusión profunda (MMBT) y la atención crossmodal sí dejan interactuar los tokens.</a:t>
+            </a:r>
+          </a:p>
+        </p:txBody>
+      </p:sp>
+    </p:spTree>
+  </p:cSld>
+  <p:clrMapOvr>
+    <a:masterClrMapping/>
+  </p:clrMapOvr>
+</p:sld>
+</file>
+
+<file path=ppt/slides/slide12.xml><?xml version="1.0" encoding="utf-8"?>
+<p:sld xmlns:a="http://schemas.openxmlformats.org/drawingml/2006/main" xmlns:p="http://schemas.openxmlformats.org/presentationml/2006/main" xmlns:r="http://schemas.openxmlformats.org/officeDocument/2006/relationships">
+  <p:cSld>
+    <p:spTree>
+      <p:nvGrpSpPr>
+        <p:cNvPr id="1" name=""/>
+        <p:cNvGrpSpPr/>
+        <p:nvPr/>
+      </p:nvGrpSpPr>
+      <p:grpSpPr/>
+      <p:sp>
+        <p:nvSpPr>
+          <p:cNvPr id="2" name="TextBox 1"/>
+          <p:cNvSpPr txBox="1"/>
+          <p:nvPr/>
+        </p:nvSpPr>
+        <p:spPr>
+          <a:xfrm>
+            <a:off x="457200" y="274320"/>
+            <a:ext cx="11247120" cy="914400"/>
+          </a:xfrm>
+          <a:prstGeom prst="rect">
+            <a:avLst/>
+          </a:prstGeom>
+          <a:noFill/>
+        </p:spPr>
+        <p:txBody>
+          <a:bodyPr wrap="square">
+            <a:spAutoFit/>
+          </a:bodyPr>
+          <a:lstStyle/>
+          <a:p>
+            <a:pPr>
+              <a:defRPr sz="2800" b="1">
+                <a:solidFill>
+                  <a:srgbClr val="0072B2"/>
+                </a:solidFill>
+              </a:defRPr>
+            </a:pPr>
+            <a:r>
+              <a:t>El pipeline (reproducible)</a:t>
+            </a:r>
+          </a:p>
+        </p:txBody>
+      </p:sp>
+      <p:sp>
+        <p:nvSpPr>
+          <p:cNvPr id="3" name="TextBox 2"/>
+          <p:cNvSpPr txBox="1"/>
+          <p:nvPr/>
+        </p:nvSpPr>
+        <p:spPr>
+          <a:xfrm>
+            <a:off x="548640" y="1280160"/>
+            <a:ext cx="11064240" cy="5120640"/>
+          </a:xfrm>
+          <a:prstGeom prst="rect">
+            <a:avLst/>
+          </a:prstGeom>
+          <a:noFill/>
+        </p:spPr>
+        <p:txBody>
+          <a:bodyPr wrap="square">
+            <a:spAutoFit/>
+          </a:bodyPr>
+          <a:lstStyle/>
+          <a:p>
+            <a:pPr>
+              <a:spcAft>
+                <a:spcPts val="700"/>
+              </a:spcAft>
+              <a:defRPr sz="1800">
+                <a:solidFill>
+                  <a:srgbClr val="333333"/>
+                </a:solidFill>
+              </a:defRPr>
+            </a:pPr>
+            <a:r>
+              <a:t>•  winoground_data.py: Winoground real (HF, gated) o set curado offline.</a:t>
+            </a:r>
+          </a:p>
+          <a:p>
+            <a:pPr>
+              <a:spcAft>
+                <a:spcPts val="700"/>
+              </a:spcAft>
+              <a:defRPr sz="1800">
+                <a:solidFill>
+                  <a:srgbClr val="333333"/>
+                </a:solidFill>
+              </a:defRPr>
+            </a:pPr>
+            <a:r>
+              <a:t>•  openclip_utils.py: embeddings L2-normalizados (motor C10).</a:t>
+            </a:r>
+          </a:p>
+          <a:p>
+            <a:pPr>
+              <a:spcAft>
+                <a:spcPts val="700"/>
+              </a:spcAft>
+              <a:defRPr sz="1800">
+                <a:solidFill>
+                  <a:srgbClr val="333333"/>
+                </a:solidFill>
+              </a:defRPr>
+            </a:pPr>
+            <a:r>
+              <a:t>•  winoground_eval.py: matriz 2×2 y los 3 scores.</a:t>
+            </a:r>
+          </a:p>
+          <a:p>
+            <a:pPr>
+              <a:spcAft>
+                <a:spcPts val="700"/>
+              </a:spcAft>
+              <a:defRPr sz="1800">
+                <a:solidFill>
+                  <a:srgbClr val="333333"/>
+                </a:solidFill>
+              </a:defRPr>
+            </a:pPr>
+            <a:r>
+              <a:t>•  metrics.py: Recall@K, intervalos bootstrap.</a:t>
+            </a:r>
+          </a:p>
+          <a:p>
+            <a:pPr>
+              <a:spcAft>
+                <a:spcPts val="700"/>
+              </a:spcAft>
+              <a:defRPr sz="1800">
+                <a:solidFill>
+                  <a:srgbClr val="333333"/>
+                </a:solidFill>
+              </a:defRPr>
+            </a:pPr>
+            <a:r>
+              <a:t>•  blindness_probe.py (¿usa la imagen?) y error_analysis.py (por tag).</a:t>
+            </a:r>
+          </a:p>
+          <a:p>
+            <a:pPr>
+              <a:spcAft>
+                <a:spcPts val="700"/>
+              </a:spcAft>
+              <a:defRPr sz="1800">
+                <a:solidFill>
+                  <a:srgbClr val="333333"/>
+                </a:solidFill>
+              </a:defRPr>
+            </a:pPr>
+            <a:r>
+              <a:t>•  Determinista (semillas), versionado, con tests. Una corrida: make run.</a:t>
+            </a:r>
+          </a:p>
+        </p:txBody>
+      </p:sp>
+    </p:spTree>
+  </p:cSld>
+  <p:clrMapOvr>
+    <a:masterClrMapping/>
+  </p:clrMapOvr>
+</p:sld>
+</file>
+
+<file path=ppt/slides/slide13.xml><?xml version="1.0" encoding="utf-8"?>
+<p:sld xmlns:a="http://schemas.openxmlformats.org/drawingml/2006/main" xmlns:p="http://schemas.openxmlformats.org/presentationml/2006/main" xmlns:r="http://schemas.openxmlformats.org/officeDocument/2006/relationships">
+  <p:cSld>
+    <p:spTree>
+      <p:nvGrpSpPr>
+        <p:cNvPr id="1" name=""/>
+        <p:cNvGrpSpPr/>
+        <p:nvPr/>
+      </p:nvGrpSpPr>
+      <p:grpSpPr/>
+      <p:sp>
+        <p:nvSpPr>
+          <p:cNvPr id="2" name="TextBox 1"/>
+          <p:cNvSpPr txBox="1"/>
+          <p:nvPr/>
+        </p:nvSpPr>
+        <p:spPr>
+          <a:xfrm>
+            <a:off x="457200" y="274320"/>
+            <a:ext cx="11247120" cy="914400"/>
+          </a:xfrm>
+          <a:prstGeom prst="rect">
+            <a:avLst/>
+          </a:prstGeom>
+          <a:noFill/>
+        </p:spPr>
+        <p:txBody>
+          <a:bodyPr wrap="square">
+            <a:spAutoFit/>
+          </a:bodyPr>
+          <a:lstStyle/>
+          <a:p>
+            <a:pPr>
+              <a:defRPr sz="2800" b="1">
+                <a:solidFill>
+                  <a:srgbClr val="0072B2"/>
+                </a:solidFill>
+              </a:defRPr>
+            </a:pPr>
+            <a:r>
+              <a:t>El bloque clave: el scorer</a:t>
+            </a:r>
+          </a:p>
+        </p:txBody>
+      </p:sp>
+      <p:sp>
+        <p:nvSpPr>
+          <p:cNvPr id="3" name="TextBox 2"/>
+          <p:cNvSpPr txBox="1"/>
+          <p:nvPr/>
+        </p:nvSpPr>
+        <p:spPr>
+          <a:xfrm>
+            <a:off x="640080" y="1371600"/>
+            <a:ext cx="10881360" cy="2926080"/>
+          </a:xfrm>
+          <a:prstGeom prst="rect">
+            <a:avLst/>
+          </a:prstGeom>
+          <a:noFill/>
+        </p:spPr>
+        <p:txBody>
+          <a:bodyPr wrap="square">
+            <a:spAutoFit/>
+          </a:bodyPr>
+          <a:lstStyle/>
+          <a:p>
+            <a:pPr>
+              <a:defRPr sz="1500">
+                <a:solidFill>
+                  <a:srgbClr val="333333"/>
+                </a:solidFill>
+                <a:latin typeface="Courier New"/>
+              </a:defRPr>
+            </a:pPr>
+            <a:r>
+              <a:t>def text_correct(sim):   # fija imagen, elige caption</a:t>
+            </a:r>
+          </a:p>
+          <a:p>
+            <a:pPr>
+              <a:defRPr sz="1500">
+                <a:solidFill>
+                  <a:srgbClr val="333333"/>
+                </a:solidFill>
+                <a:latin typeface="Courier New"/>
+              </a:defRPr>
+            </a:pPr>
+            <a:r>
+              <a:t>    return sim[0,0] &gt; sim[1,0] and sim[1,1] &gt; sim[0,1]</a:t>
+            </a:r>
+          </a:p>
+          <a:p>
+            <a:pPr>
+              <a:defRPr sz="1500">
+                <a:solidFill>
+                  <a:srgbClr val="333333"/>
+                </a:solidFill>
+                <a:latin typeface="Courier New"/>
+              </a:defRPr>
+            </a:pPr>
+          </a:p>
+          <a:p>
+            <a:pPr>
+              <a:defRPr sz="1500">
+                <a:solidFill>
+                  <a:srgbClr val="333333"/>
+                </a:solidFill>
+                <a:latin typeface="Courier New"/>
+              </a:defRPr>
+            </a:pPr>
+            <a:r>
+              <a:t>def image_correct(sim):  # fija caption, elige imagen</a:t>
+            </a:r>
+          </a:p>
+          <a:p>
+            <a:pPr>
+              <a:defRPr sz="1500">
+                <a:solidFill>
+                  <a:srgbClr val="333333"/>
+                </a:solidFill>
+                <a:latin typeface="Courier New"/>
+              </a:defRPr>
+            </a:pPr>
+            <a:r>
+              <a:t>    return sim[0,0] &gt; sim[0,1] and sim[1,1] &gt; sim[1,0]</a:t>
+            </a:r>
+          </a:p>
+          <a:p>
+            <a:pPr>
+              <a:defRPr sz="1500">
+                <a:solidFill>
+                  <a:srgbClr val="333333"/>
+                </a:solidFill>
+                <a:latin typeface="Courier New"/>
+              </a:defRPr>
+            </a:pPr>
+          </a:p>
+          <a:p>
+            <a:pPr>
+              <a:defRPr sz="1500">
+                <a:solidFill>
+                  <a:srgbClr val="333333"/>
+                </a:solidFill>
+                <a:latin typeface="Courier New"/>
+              </a:defRPr>
+            </a:pPr>
+            <a:r>
+              <a:t>def group_correct(sim):</a:t>
+            </a:r>
+          </a:p>
+          <a:p>
+            <a:pPr>
+              <a:defRPr sz="1500">
+                <a:solidFill>
+                  <a:srgbClr val="333333"/>
+                </a:solidFill>
+                <a:latin typeface="Courier New"/>
+              </a:defRPr>
+            </a:pPr>
+            <a:r>
+              <a:t>    return text_correct(sim) and image_correct(sim)</a:t>
+            </a:r>
+          </a:p>
+        </p:txBody>
+      </p:sp>
+      <p:sp>
+        <p:nvSpPr>
+          <p:cNvPr id="4" name="TextBox 3"/>
+          <p:cNvSpPr txBox="1"/>
+          <p:nvPr/>
+        </p:nvSpPr>
+        <p:spPr>
+          <a:xfrm>
+            <a:off x="548640" y="6126480"/>
+            <a:ext cx="11064240" cy="640080"/>
+          </a:xfrm>
+          <a:prstGeom prst="rect">
+            <a:avLst/>
+          </a:prstGeom>
+          <a:noFill/>
+        </p:spPr>
+        <p:txBody>
+          <a:bodyPr wrap="square">
+            <a:spAutoFit/>
+          </a:bodyPr>
+          <a:lstStyle/>
+          <a:p>
+            <a:pPr>
+              <a:defRPr sz="1300">
+                <a:solidFill>
+                  <a:srgbClr val="0072B2"/>
+                </a:solidFill>
+              </a:defRPr>
+            </a:pPr>
+            <a:r>
+              <a:t>Es el código oficial de Winoground; me guié por el código (no por la redacción) y lo validé numéricamente.</a:t>
+            </a:r>
+          </a:p>
+        </p:txBody>
+      </p:sp>
+    </p:spTree>
+  </p:cSld>
+  <p:clrMapOvr>
+    <a:masterClrMapping/>
+  </p:clrMapOvr>
+</p:sld>
+</file>
+
+<file path=ppt/slides/slide14.xml><?xml version="1.0" encoding="utf-8"?>
+<p:sld xmlns:a="http://schemas.openxmlformats.org/drawingml/2006/main" xmlns:p="http://schemas.openxmlformats.org/presentationml/2006/main" xmlns:r="http://schemas.openxmlformats.org/officeDocument/2006/relationships">
+  <p:cSld>
+    <p:spTree>
+      <p:nvGrpSpPr>
+        <p:cNvPr id="1" name=""/>
+        <p:cNvGrpSpPr/>
+        <p:nvPr/>
+      </p:nvGrpSpPr>
+      <p:grpSpPr/>
+      <p:sp>
+        <p:nvSpPr>
+          <p:cNvPr id="2" name="TextBox 1"/>
+          <p:cNvSpPr txBox="1"/>
+          <p:nvPr/>
+        </p:nvSpPr>
+        <p:spPr>
+          <a:xfrm>
+            <a:off x="457200" y="274320"/>
+            <a:ext cx="11247120" cy="914400"/>
+          </a:xfrm>
+          <a:prstGeom prst="rect">
+            <a:avLst/>
+          </a:prstGeom>
+          <a:noFill/>
+        </p:spPr>
+        <p:txBody>
+          <a:bodyPr wrap="square">
+            <a:spAutoFit/>
+          </a:bodyPr>
+          <a:lstStyle/>
+          <a:p>
+            <a:pPr>
+              <a:defRPr sz="2800" b="1">
+                <a:solidFill>
+                  <a:srgbClr val="0072B2"/>
+                </a:solidFill>
+              </a:defRPr>
+            </a:pPr>
+            <a:r>
+              <a:t>¿Cómo sé que mi scorer no está mal?</a:t>
+            </a:r>
+          </a:p>
+        </p:txBody>
+      </p:sp>
+      <p:sp>
+        <p:nvSpPr>
+          <p:cNvPr id="3" name="TextBox 2"/>
+          <p:cNvSpPr txBox="1"/>
+          <p:nvPr/>
+        </p:nvSpPr>
+        <p:spPr>
+          <a:xfrm>
+            <a:off x="548640" y="1280160"/>
+            <a:ext cx="11064240" cy="5120640"/>
+          </a:xfrm>
+          <a:prstGeom prst="rect">
+            <a:avLst/>
+          </a:prstGeom>
+          <a:noFill/>
+        </p:spPr>
+        <p:txBody>
+          <a:bodyPr wrap="square">
+            <a:spAutoFit/>
+          </a:bodyPr>
+          <a:lstStyle/>
+          <a:p>
+            <a:pPr>
+              <a:spcAft>
+                <a:spcPts val="700"/>
+              </a:spcAft>
+              <a:defRPr sz="1800">
+                <a:solidFill>
+                  <a:srgbClr val="333333"/>
+                </a:solidFill>
+              </a:defRPr>
+            </a:pPr>
+            <a:r>
+              <a:t>•  Lo apliqué a los scores oficiales de CLIP del propio dataset (statistics/model_scores/clip.jsonl).</a:t>
+            </a:r>
+          </a:p>
+          <a:p>
+            <a:pPr>
+              <a:spcAft>
+                <a:spcPts val="700"/>
+              </a:spcAft>
+              <a:defRPr sz="1800">
+                <a:solidFill>
+                  <a:srgbClr val="333333"/>
+                </a:solidFill>
+              </a:defRPr>
+            </a:pPr>
+            <a:r>
+              <a:t>•  Paper CLIP ViT-B/32:  text=0.3075,  image=0.1050,  group=0.0800.</a:t>
+            </a:r>
+          </a:p>
+          <a:p>
+            <a:pPr>
+              <a:spcAft>
+                <a:spcPts val="700"/>
+              </a:spcAft>
+              <a:defRPr sz="1800">
+                <a:solidFill>
+                  <a:srgbClr val="333333"/>
+                </a:solidFill>
+              </a:defRPr>
+            </a:pPr>
+            <a:r>
+              <a:t>•  Mi scorer:            text=0.3075,  image=0.1050,  group=0.0800.  → coincidencia EXACTA.</a:t>
+            </a:r>
+          </a:p>
+          <a:p>
+            <a:pPr>
+              <a:spcAft>
+                <a:spcPts val="700"/>
+              </a:spcAft>
+              <a:defRPr sz="1800">
+                <a:solidFill>
+                  <a:srgbClr val="333333"/>
+                </a:solidFill>
+              </a:defRPr>
+            </a:pPr>
+            <a:r>
+              <a:t>•  python scripts/validate_against_official.py</a:t>
+            </a:r>
+          </a:p>
+        </p:txBody>
+      </p:sp>
+    </p:spTree>
+  </p:cSld>
+  <p:clrMapOvr>
+    <a:masterClrMapping/>
+  </p:clrMapOvr>
+</p:sld>
+</file>
+
+<file path=ppt/slides/slide15.xml><?xml version="1.0" encoding="utf-8"?>
+<p:sld xmlns:a="http://schemas.openxmlformats.org/drawingml/2006/main" xmlns:p="http://schemas.openxmlformats.org/presentationml/2006/main" xmlns:r="http://schemas.openxmlformats.org/officeDocument/2006/relationships">
+  <p:cSld>
+    <p:spTree>
+      <p:nvGrpSpPr>
+        <p:cNvPr id="1" name=""/>
+        <p:cNvGrpSpPr/>
+        <p:nvPr/>
+      </p:nvGrpSpPr>
+      <p:grpSpPr/>
+      <p:sp>
+        <p:nvSpPr>
+          <p:cNvPr id="2" name="TextBox 1"/>
+          <p:cNvSpPr txBox="1"/>
+          <p:nvPr/>
+        </p:nvSpPr>
+        <p:spPr>
+          <a:xfrm>
+            <a:off x="731520" y="2743200"/>
+            <a:ext cx="10698480" cy="1371600"/>
+          </a:xfrm>
+          <a:prstGeom prst="rect">
+            <a:avLst/>
+          </a:prstGeom>
+          <a:noFill/>
+        </p:spPr>
+        <p:txBody>
+          <a:bodyPr wrap="none">
+            <a:spAutoFit/>
+          </a:bodyPr>
+          <a:lstStyle/>
+          <a:p>
+            <a:pPr>
+              <a:defRPr sz="3400" b="1">
+                <a:solidFill>
+                  <a:srgbClr val="0072B2"/>
+                </a:solidFill>
+              </a:defRPr>
+            </a:pPr>
+            <a:r>
+              <a:t>3 · Resultados</a:t>
+            </a:r>
+          </a:p>
+        </p:txBody>
+      </p:sp>
+    </p:spTree>
+  </p:cSld>
+  <p:clrMapOvr>
+    <a:masterClrMapping/>
+  </p:clrMapOvr>
+</p:sld>
+</file>
+
+<file path=ppt/slides/slide16.xml><?xml version="1.0" encoding="utf-8"?>
+<p:sld xmlns:a="http://schemas.openxmlformats.org/drawingml/2006/main" xmlns:p="http://schemas.openxmlformats.org/presentationml/2006/main" xmlns:r="http://schemas.openxmlformats.org/officeDocument/2006/relationships">
+  <p:cSld>
+    <p:spTree>
+      <p:nvGrpSpPr>
+        <p:cNvPr id="1" name=""/>
+        <p:cNvGrpSpPr/>
+        <p:nvPr/>
+      </p:nvGrpSpPr>
+      <p:grpSpPr/>
+      <p:sp>
+        <p:nvSpPr>
+          <p:cNvPr id="2" name="TextBox 1"/>
+          <p:cNvSpPr txBox="1"/>
+          <p:nvPr/>
+        </p:nvSpPr>
+        <p:spPr>
+          <a:xfrm>
+            <a:off x="457200" y="274320"/>
+            <a:ext cx="11247120" cy="914400"/>
+          </a:xfrm>
+          <a:prstGeom prst="rect">
+            <a:avLst/>
+          </a:prstGeom>
+          <a:noFill/>
+        </p:spPr>
+        <p:txBody>
+          <a:bodyPr wrap="square">
+            <a:spAutoFit/>
+          </a:bodyPr>
+          <a:lstStyle/>
+          <a:p>
+            <a:pPr>
+              <a:defRPr sz="2800" b="1">
+                <a:solidFill>
+                  <a:srgbClr val="0072B2"/>
+                </a:solidFill>
+              </a:defRPr>
+            </a:pPr>
+            <a:r>
+              <a:t>Resultado principal: los tres scores</a:t>
+            </a:r>
+          </a:p>
+        </p:txBody>
+      </p:sp>
+      <p:pic>
+        <p:nvPicPr>
+          <p:cNvPr id="3" name="Picture 2" descr="scores_vs_chance.png"/>
+          <p:cNvPicPr>
+            <a:picLocks noChangeAspect="1"/>
+          </p:cNvPicPr>
+          <p:nvPr/>
+        </p:nvPicPr>
+        <p:blipFill>
+          <a:blip r:embed="rId2"/>
+          <a:stretch>
+            <a:fillRect/>
+          </a:stretch>
+        </p:blipFill>
+        <p:spPr>
+          <a:xfrm>
+            <a:off x="2651760" y="1280160"/>
+            <a:ext cx="7396480" cy="4754880"/>
+          </a:xfrm>
+          <a:prstGeom prst="rect">
+            <a:avLst/>
+          </a:prstGeom>
+        </p:spPr>
+      </p:pic>
+      <p:sp>
+        <p:nvSpPr>
+          <p:cNvPr id="4" name="TextBox 3"/>
+          <p:cNvSpPr txBox="1"/>
+          <p:nvPr/>
+        </p:nvSpPr>
+        <p:spPr>
+          <a:xfrm>
+            <a:off x="548640" y="6126480"/>
+            <a:ext cx="11064240" cy="640080"/>
+          </a:xfrm>
+          <a:prstGeom prst="rect">
+            <a:avLst/>
+          </a:prstGeom>
+          <a:noFill/>
+        </p:spPr>
+        <p:txBody>
+          <a:bodyPr wrap="square">
+            <a:spAutoFit/>
+          </a:bodyPr>
+          <a:lstStyle/>
+          <a:p>
+            <a:pPr>
+              <a:defRPr sz="1300">
+                <a:solidFill>
+                  <a:srgbClr val="0072B2"/>
+                </a:solidFill>
+              </a:defRPr>
+            </a:pPr>
+            <a:r>
+              <a:t>ViT-B-32/laion2b, 400 ejemplos reales. text=0.35, image=0.11, group=0.075 (azar 0.167; humano 0.86).</a:t>
+            </a:r>
+          </a:p>
+        </p:txBody>
+      </p:sp>
+    </p:spTree>
+  </p:cSld>
+  <p:clrMapOvr>
+    <a:masterClrMapping/>
+  </p:clrMapOvr>
+</p:sld>
+</file>
+
+<file path=ppt/slides/slide17.xml><?xml version="1.0" encoding="utf-8"?>
+<p:sld xmlns:a="http://schemas.openxmlformats.org/drawingml/2006/main" xmlns:p="http://schemas.openxmlformats.org/presentationml/2006/main" xmlns:r="http://schemas.openxmlformats.org/officeDocument/2006/relationships">
+  <p:cSld>
+    <p:spTree>
+      <p:nvGrpSpPr>
+        <p:cNvPr id="1" name=""/>
+        <p:cNvGrpSpPr/>
+        <p:nvPr/>
+      </p:nvGrpSpPr>
+      <p:grpSpPr/>
+      <p:sp>
+        <p:nvSpPr>
+          <p:cNvPr id="2" name="TextBox 1"/>
+          <p:cNvSpPr txBox="1"/>
+          <p:nvPr/>
+        </p:nvSpPr>
+        <p:spPr>
+          <a:xfrm>
+            <a:off x="457200" y="274320"/>
+            <a:ext cx="11247120" cy="914400"/>
+          </a:xfrm>
+          <a:prstGeom prst="rect">
+            <a:avLst/>
+          </a:prstGeom>
+          <a:noFill/>
+        </p:spPr>
+        <p:txBody>
+          <a:bodyPr wrap="square">
+            <a:spAutoFit/>
+          </a:bodyPr>
+          <a:lstStyle/>
+          <a:p>
+            <a:pPr>
+              <a:defRPr sz="2800" b="1">
+                <a:solidFill>
+                  <a:srgbClr val="0072B2"/>
+                </a:solidFill>
+              </a:defRPr>
+            </a:pPr>
+            <a:r>
+              <a:t>Cómo leer ese resultado</a:t>
+            </a:r>
+          </a:p>
+        </p:txBody>
+      </p:sp>
+      <p:sp>
+        <p:nvSpPr>
+          <p:cNvPr id="3" name="TextBox 2"/>
+          <p:cNvSpPr txBox="1"/>
+          <p:nvPr/>
+        </p:nvSpPr>
+        <p:spPr>
+          <a:xfrm>
+            <a:off x="548640" y="1280160"/>
+            <a:ext cx="11064240" cy="5120640"/>
+          </a:xfrm>
+          <a:prstGeom prst="rect">
+            <a:avLst/>
+          </a:prstGeom>
+          <a:noFill/>
+        </p:spPr>
+        <p:txBody>
+          <a:bodyPr wrap="square">
+            <a:spAutoFit/>
+          </a:bodyPr>
+          <a:lstStyle/>
+          <a:p>
+            <a:pPr>
+              <a:spcAft>
+                <a:spcPts val="700"/>
+              </a:spcAft>
+              <a:defRPr sz="1800">
+                <a:solidFill>
+                  <a:srgbClr val="333333"/>
+                </a:solidFill>
+              </a:defRPr>
+            </a:pPr>
+            <a:r>
+              <a:t>•  text (0.35) está POR ENCIMA del azar (0.25): el modelo capta algo.</a:t>
+            </a:r>
+          </a:p>
+          <a:p>
+            <a:pPr>
+              <a:spcAft>
+                <a:spcPts val="700"/>
+              </a:spcAft>
+              <a:defRPr sz="1800">
+                <a:solidFill>
+                  <a:srgbClr val="333333"/>
+                </a:solidFill>
+              </a:defRPr>
+            </a:pPr>
+            <a:r>
+              <a:t>•  group (0.075) está POR DEBAJO del azar (0.167).</a:t>
+            </a:r>
+          </a:p>
+          <a:p>
+            <a:pPr>
+              <a:spcAft>
+                <a:spcPts val="700"/>
+              </a:spcAft>
+              <a:defRPr sz="1800">
+                <a:solidFill>
+                  <a:srgbClr val="333333"/>
+                </a:solidFill>
+              </a:defRPr>
+            </a:pPr>
+            <a:r>
+              <a:t>•  No es 'peor que aleatorio' en general: es la asimetría text ≫ image (acierta una dirección y falla la otra).</a:t>
+            </a:r>
+          </a:p>
+          <a:p>
+            <a:pPr>
+              <a:spcAft>
+                <a:spcPts val="700"/>
+              </a:spcAft>
+              <a:defRPr sz="1800">
+                <a:solidFill>
+                  <a:srgbClr val="333333"/>
+                </a:solidFill>
+              </a:defRPr>
+            </a:pPr>
+            <a:r>
+              <a:t>•  El IC bootstrap 95% del group [0.05, 0.10] queda entero por debajo del azar.</a:t>
+            </a:r>
+          </a:p>
+        </p:txBody>
+      </p:sp>
+    </p:spTree>
+  </p:cSld>
+  <p:clrMapOvr>
+    <a:masterClrMapping/>
+  </p:clrMapOvr>
+</p:sld>
+</file>
+
+<file path=ppt/slides/slide18.xml><?xml version="1.0" encoding="utf-8"?>
+<p:sld xmlns:a="http://schemas.openxmlformats.org/drawingml/2006/main" xmlns:p="http://schemas.openxmlformats.org/presentationml/2006/main" xmlns:r="http://schemas.openxmlformats.org/officeDocument/2006/relationships">
+  <p:cSld>
+    <p:spTree>
+      <p:nvGrpSpPr>
+        <p:cNvPr id="1" name=""/>
+        <p:cNvGrpSpPr/>
+        <p:nvPr/>
+      </p:nvGrpSpPr>
+      <p:grpSpPr/>
+      <p:sp>
+        <p:nvSpPr>
+          <p:cNvPr id="2" name="TextBox 1"/>
+          <p:cNvSpPr txBox="1"/>
+          <p:nvPr/>
+        </p:nvSpPr>
+        <p:spPr>
+          <a:xfrm>
+            <a:off x="457200" y="274320"/>
+            <a:ext cx="11247120" cy="914400"/>
+          </a:xfrm>
+          <a:prstGeom prst="rect">
+            <a:avLst/>
+          </a:prstGeom>
+          <a:noFill/>
+        </p:spPr>
+        <p:txBody>
+          <a:bodyPr wrap="square">
+            <a:spAutoFit/>
+          </a:bodyPr>
+          <a:lstStyle/>
+          <a:p>
+            <a:pPr>
+              <a:defRPr sz="2800" b="1">
+                <a:solidFill>
+                  <a:srgbClr val="0072B2"/>
+                </a:solidFill>
+              </a:defRPr>
+            </a:pPr>
+            <a:r>
+              <a:t>La evidencia de la tesis: retrieval alto, group bajo</a:t>
+            </a:r>
+          </a:p>
+        </p:txBody>
+      </p:sp>
+      <p:pic>
+        <p:nvPicPr>
+          <p:cNvPr id="3" name="Picture 2" descr="recall_vs_group.png"/>
+          <p:cNvPicPr>
+            <a:picLocks noChangeAspect="1"/>
+          </p:cNvPicPr>
+          <p:nvPr/>
+        </p:nvPicPr>
+        <p:blipFill>
+          <a:blip r:embed="rId2"/>
+          <a:stretch>
+            <a:fillRect/>
+          </a:stretch>
+        </p:blipFill>
+        <p:spPr>
+          <a:xfrm>
+            <a:off x="2743200" y="1280160"/>
+            <a:ext cx="7620000" cy="4572000"/>
+          </a:xfrm>
+          <a:prstGeom prst="rect">
+            <a:avLst/>
+          </a:prstGeom>
+        </p:spPr>
+      </p:pic>
+      <p:sp>
+        <p:nvSpPr>
+          <p:cNvPr id="4" name="TextBox 3"/>
+          <p:cNvSpPr txBox="1"/>
+          <p:nvPr/>
+        </p:nvSpPr>
+        <p:spPr>
+          <a:xfrm>
+            <a:off x="548640" y="6126480"/>
+            <a:ext cx="11064240" cy="640080"/>
+          </a:xfrm>
+          <a:prstGeom prst="rect">
+            <a:avLst/>
+          </a:prstGeom>
+          <a:noFill/>
+        </p:spPr>
+        <p:txBody>
+          <a:bodyPr wrap="square">
+            <a:spAutoFit/>
+          </a:bodyPr>
+          <a:lstStyle/>
+          <a:p>
+            <a:pPr>
+              <a:defRPr sz="1300">
+                <a:solidFill>
+                  <a:srgbClr val="0072B2"/>
+                </a:solidFill>
+              </a:defRPr>
+            </a:pPr>
+            <a:r>
+              <a:t>Mismo conjunto: R@5=0.67, R@10=0.77 pero group=0.075. Retrieval usa toda la galería; group exige el par mínimo.</a:t>
+            </a:r>
+          </a:p>
+        </p:txBody>
+      </p:sp>
+    </p:spTree>
+  </p:cSld>
+  <p:clrMapOvr>
+    <a:masterClrMapping/>
+  </p:clrMapOvr>
+</p:sld>
+</file>
+
+<file path=ppt/slides/slide19.xml><?xml version="1.0" encoding="utf-8"?>
+<p:sld xmlns:a="http://schemas.openxmlformats.org/drawingml/2006/main" xmlns:p="http://schemas.openxmlformats.org/presentationml/2006/main" xmlns:r="http://schemas.openxmlformats.org/officeDocument/2006/relationships">
+  <p:cSld>
+    <p:spTree>
+      <p:nvGrpSpPr>
+        <p:cNvPr id="1" name=""/>
+        <p:cNvGrpSpPr/>
+        <p:nvPr/>
+      </p:nvGrpSpPr>
+      <p:grpSpPr/>
+      <p:sp>
+        <p:nvSpPr>
+          <p:cNvPr id="2" name="TextBox 1"/>
+          <p:cNvSpPr txBox="1"/>
+          <p:nvPr/>
+        </p:nvSpPr>
+        <p:spPr>
+          <a:xfrm>
+            <a:off x="457200" y="274320"/>
+            <a:ext cx="11247120" cy="914400"/>
+          </a:xfrm>
+          <a:prstGeom prst="rect">
+            <a:avLst/>
+          </a:prstGeom>
+          <a:noFill/>
+        </p:spPr>
+        <p:txBody>
+          <a:bodyPr wrap="square">
+            <a:spAutoFit/>
+          </a:bodyPr>
+          <a:lstStyle/>
+          <a:p>
+            <a:pPr>
+              <a:defRPr sz="2800" b="1">
+                <a:solidFill>
+                  <a:srgbClr val="0072B2"/>
+                </a:solidFill>
+              </a:defRPr>
+            </a:pPr>
+            <a:r>
+              <a:t>¿Qué tipo de error? Análisis por tag</a:t>
+            </a:r>
+          </a:p>
+        </p:txBody>
+      </p:sp>
+      <p:pic>
+        <p:nvPicPr>
+          <p:cNvPr id="3" name="Picture 2" descr="by_tag.png"/>
+          <p:cNvPicPr>
+            <a:picLocks noChangeAspect="1"/>
+          </p:cNvPicPr>
+          <p:nvPr/>
+        </p:nvPicPr>
+        <p:blipFill>
+          <a:blip r:embed="rId2"/>
+          <a:stretch>
+            <a:fillRect/>
+          </a:stretch>
+        </p:blipFill>
+        <p:spPr>
+          <a:xfrm>
+            <a:off x="2926080" y="1280160"/>
+            <a:ext cx="7467600" cy="4480560"/>
+          </a:xfrm>
+          <a:prstGeom prst="rect">
+            <a:avLst/>
+          </a:prstGeom>
+        </p:spPr>
+      </p:pic>
+      <p:sp>
+        <p:nvSpPr>
+          <p:cNvPr id="4" name="TextBox 3"/>
+          <p:cNvSpPr txBox="1"/>
+          <p:nvPr/>
+        </p:nvSpPr>
+        <p:spPr>
+          <a:xfrm>
+            <a:off x="548640" y="6126480"/>
+            <a:ext cx="11064240" cy="640080"/>
+          </a:xfrm>
+          <a:prstGeom prst="rect">
+            <a:avLst/>
+          </a:prstGeom>
+          <a:noFill/>
+        </p:spPr>
+        <p:txBody>
+          <a:bodyPr wrap="square">
+            <a:spAutoFit/>
+          </a:bodyPr>
+          <a:lstStyle/>
+          <a:p>
+            <a:pPr>
+              <a:defRPr sz="1300">
+                <a:solidFill>
+                  <a:srgbClr val="0072B2"/>
+                </a:solidFill>
+              </a:defRPr>
+            </a:pPr>
+            <a:r>
+              <a:t>Relation es lo más difícil (group 0.047). Fallos de vinculación, no de reconocimiento.</a:t>
             </a:r>
           </a:p>
         </p:txBody>
@@ -3201,20 +4530,20 @@
           <a:noFill/>
         </p:spPr>
         <p:txBody>
-          <a:bodyPr wrap="none">
+          <a:bodyPr wrap="square">
             <a:spAutoFit/>
           </a:bodyPr>
           <a:lstStyle/>
           <a:p>
             <a:pPr>
-              <a:defRPr sz="3000" b="1">
+              <a:defRPr sz="2800" b="1">
                 <a:solidFill>
                   <a:srgbClr val="0072B2"/>
                 </a:solidFill>
               </a:defRPr>
             </a:pPr>
             <a:r>
-              <a:t>Recordatorio: paper y resultado (2 min)</a:t>
+              <a:t>Qué voy a defender en 15 minutos</a:t>
             </a:r>
           </a:p>
         </p:txBody>
@@ -3228,7 +4557,7 @@
         <p:spPr>
           <a:xfrm>
             <a:off x="548640" y="1280160"/>
-            <a:ext cx="5486400" cy="5029200"/>
+            <a:ext cx="11064240" cy="5120640"/>
           </a:xfrm>
           <a:prstGeom prst="rect">
             <a:avLst/>
@@ -3243,7 +4572,7 @@
           <a:p>
             <a:pPr>
               <a:spcAft>
-                <a:spcPts val="800"/>
+                <a:spcPts val="700"/>
               </a:spcAft>
               <a:defRPr sz="1800">
                 <a:solidFill>
@@ -3252,13 +4581,13 @@
               </a:defRPr>
             </a:pPr>
             <a:r>
-              <a:t>•  Winoground: pares mínimos (2 imágenes, 2 captions, mismas palabras, distinto orden).</a:t>
+              <a:t>•  El problema: ¿CLIP entiende o solo empareja? (Winoground)</a:t>
             </a:r>
           </a:p>
           <a:p>
             <a:pPr>
               <a:spcAft>
-                <a:spcPts val="800"/>
+                <a:spcPts val="700"/>
               </a:spcAft>
               <a:defRPr sz="1800">
                 <a:solidFill>
@@ -3267,13 +4596,13 @@
               </a:defRPr>
             </a:pPr>
             <a:r>
-              <a:t>•  Mide composición, no reconocimiento. Azar: text=image=1/4, group=1/6.</a:t>
+              <a:t>•  Cómo lo medí reutilizando el motor OpenCLIP del Cuaderno 10.</a:t>
             </a:r>
           </a:p>
           <a:p>
             <a:pPr>
               <a:spcAft>
-                <a:spcPts val="800"/>
+                <a:spcPts val="700"/>
               </a:spcAft>
               <a:defRPr sz="1800">
                 <a:solidFill>
@@ -3282,13 +4611,13 @@
               </a:defRPr>
             </a:pPr>
             <a:r>
-              <a:t>•  Evaluating CLIP: mayor accuracy no implica mejor modelo (sesgos, diseño de clases).</a:t>
+              <a:t>•  El resultado: retrieval alto, group score ≈ azar.</a:t>
             </a:r>
           </a:p>
           <a:p>
             <a:pPr>
               <a:spcAft>
-                <a:spcPts val="800"/>
+                <a:spcPts val="700"/>
               </a:spcAft>
               <a:defRPr sz="1800">
                 <a:solidFill>
@@ -3297,14 +4626,117 @@
               </a:defRPr>
             </a:pPr>
             <a:r>
-              <a:t>•  Resultado: Recall@K alto, pero group score ≈ azar.</a:t>
+              <a:t>•  Verificación en vivo + validación contra los scores oficiales.</a:t>
+            </a:r>
+          </a:p>
+          <a:p>
+            <a:pPr>
+              <a:spcAft>
+                <a:spcPts val="700"/>
+              </a:spcAft>
+              <a:defRPr sz="1800">
+                <a:solidFill>
+                  <a:srgbClr val="333333"/>
+                </a:solidFill>
+              </a:defRPr>
+            </a:pPr>
+            <a:r>
+              <a:t>•  Por qué pasa (C5, C8), limitaciones y mejora.</a:t>
+            </a:r>
+          </a:p>
+        </p:txBody>
+      </p:sp>
+      <p:sp>
+        <p:nvSpPr>
+          <p:cNvPr id="4" name="TextBox 3"/>
+          <p:cNvSpPr txBox="1"/>
+          <p:nvPr/>
+        </p:nvSpPr>
+        <p:spPr>
+          <a:xfrm>
+            <a:off x="548640" y="6126480"/>
+            <a:ext cx="11064240" cy="640080"/>
+          </a:xfrm>
+          <a:prstGeom prst="rect">
+            <a:avLst/>
+          </a:prstGeom>
+          <a:noFill/>
+        </p:spPr>
+        <p:txBody>
+          <a:bodyPr wrap="square">
+            <a:spAutoFit/>
+          </a:bodyPr>
+          <a:lstStyle/>
+          <a:p>
+            <a:pPr>
+              <a:defRPr sz="1300">
+                <a:solidFill>
+                  <a:srgbClr val="0072B2"/>
+                </a:solidFill>
+              </a:defRPr>
+            </a:pPr>
+            <a:r>
+              <a:t>Tesis: recuperar bien una imagen no prueba que el modelo entienda el orden ni las relaciones.</a:t>
+            </a:r>
+          </a:p>
+        </p:txBody>
+      </p:sp>
+    </p:spTree>
+  </p:cSld>
+  <p:clrMapOvr>
+    <a:masterClrMapping/>
+  </p:clrMapOvr>
+</p:sld>
+</file>
+
+<file path=ppt/slides/slide20.xml><?xml version="1.0" encoding="utf-8"?>
+<p:sld xmlns:a="http://schemas.openxmlformats.org/drawingml/2006/main" xmlns:p="http://schemas.openxmlformats.org/presentationml/2006/main" xmlns:r="http://schemas.openxmlformats.org/officeDocument/2006/relationships">
+  <p:cSld>
+    <p:spTree>
+      <p:nvGrpSpPr>
+        <p:cNvPr id="1" name=""/>
+        <p:cNvGrpSpPr/>
+        <p:nvPr/>
+      </p:nvGrpSpPr>
+      <p:grpSpPr/>
+      <p:sp>
+        <p:nvSpPr>
+          <p:cNvPr id="2" name="TextBox 1"/>
+          <p:cNvSpPr txBox="1"/>
+          <p:nvPr/>
+        </p:nvSpPr>
+        <p:spPr>
+          <a:xfrm>
+            <a:off x="457200" y="274320"/>
+            <a:ext cx="11247120" cy="914400"/>
+          </a:xfrm>
+          <a:prstGeom prst="rect">
+            <a:avLst/>
+          </a:prstGeom>
+          <a:noFill/>
+        </p:spPr>
+        <p:txBody>
+          <a:bodyPr wrap="square">
+            <a:spAutoFit/>
+          </a:bodyPr>
+          <a:lstStyle/>
+          <a:p>
+            <a:pPr>
+              <a:defRPr sz="2800" b="1">
+                <a:solidFill>
+                  <a:srgbClr val="0072B2"/>
+                </a:solidFill>
+              </a:defRPr>
+            </a:pPr>
+            <a:r>
+              <a:t>¿El modelo usa la imagen? Prueba de ceguera</a:t>
             </a:r>
           </a:p>
         </p:txBody>
       </p:sp>
       <p:pic>
         <p:nvPicPr>
-          <p:cNvPr id="4" name="Picture 3" descr="recall_vs_group.png"/>
+          <p:cNvPr id="3" name="Picture 2" descr="blindness.png"/>
           <p:cNvPicPr>
             <a:picLocks noChangeAspect="1"/>
           </p:cNvPicPr>
@@ -3318,14 +4750,1188 @@
         </p:blipFill>
         <p:spPr>
           <a:xfrm>
-            <a:off x="6400800" y="1371600"/>
-            <a:ext cx="7010400" cy="4206240"/>
+            <a:off x="457200" y="1280160"/>
+            <a:ext cx="7112000" cy="4572000"/>
           </a:xfrm>
           <a:prstGeom prst="rect">
             <a:avLst/>
           </a:prstGeom>
         </p:spPr>
       </p:pic>
+      <p:sp>
+        <p:nvSpPr>
+          <p:cNvPr id="4" name="TextBox 3"/>
+          <p:cNvSpPr txBox="1"/>
+          <p:nvPr/>
+        </p:nvSpPr>
+        <p:spPr>
+          <a:xfrm>
+            <a:off x="6400800" y="1463040"/>
+            <a:ext cx="5303520" cy="5120640"/>
+          </a:xfrm>
+          <a:prstGeom prst="rect">
+            <a:avLst/>
+          </a:prstGeom>
+          <a:noFill/>
+        </p:spPr>
+        <p:txBody>
+          <a:bodyPr wrap="square">
+            <a:spAutoFit/>
+          </a:bodyPr>
+          <a:lstStyle/>
+          <a:p>
+            <a:pPr>
+              <a:spcAft>
+                <a:spcPts val="700"/>
+              </a:spcAft>
+              <a:defRPr sz="1500">
+                <a:solidFill>
+                  <a:srgbClr val="333333"/>
+                </a:solidFill>
+              </a:defRPr>
+            </a:pPr>
+            <a:r>
+              <a:t>•  Permuto las imágenes entre ejemplos y recalculo.</a:t>
+            </a:r>
+          </a:p>
+          <a:p>
+            <a:pPr>
+              <a:spcAft>
+                <a:spcPts val="700"/>
+              </a:spcAft>
+              <a:defRPr sz="1500">
+                <a:solidFill>
+                  <a:srgbClr val="333333"/>
+                </a:solidFill>
+              </a:defRPr>
+            </a:pPr>
+            <a:r>
+              <a:t>•  Real (0.35/0.11/0.075) → permutado (0.14/0.04/0.02).</a:t>
+            </a:r>
+          </a:p>
+          <a:p>
+            <a:pPr>
+              <a:spcAft>
+                <a:spcPts val="700"/>
+              </a:spcAft>
+              <a:defRPr sz="1500">
+                <a:solidFill>
+                  <a:srgbClr val="333333"/>
+                </a:solidFill>
+              </a:defRPr>
+            </a:pPr>
+            <a:r>
+              <a:t>•  Sí usa la imagen; su límite es composicional, no perceptivo.</a:t>
+            </a:r>
+          </a:p>
+          <a:p>
+            <a:pPr>
+              <a:spcAft>
+                <a:spcPts val="700"/>
+              </a:spcAft>
+              <a:defRPr sz="1500">
+                <a:solidFill>
+                  <a:srgbClr val="333333"/>
+                </a:solidFill>
+              </a:defRPr>
+            </a:pPr>
+            <a:r>
+              <a:t>•  Versión cuantitativa de la interpretabilidad de C8.</a:t>
+            </a:r>
+          </a:p>
+        </p:txBody>
+      </p:sp>
+    </p:spTree>
+  </p:cSld>
+  <p:clrMapOvr>
+    <a:masterClrMapping/>
+  </p:clrMapOvr>
+</p:sld>
+</file>
+
+<file path=ppt/slides/slide21.xml><?xml version="1.0" encoding="utf-8"?>
+<p:sld xmlns:a="http://schemas.openxmlformats.org/drawingml/2006/main" xmlns:p="http://schemas.openxmlformats.org/presentationml/2006/main" xmlns:r="http://schemas.openxmlformats.org/officeDocument/2006/relationships">
+  <p:cSld>
+    <p:spTree>
+      <p:nvGrpSpPr>
+        <p:cNvPr id="1" name=""/>
+        <p:cNvGrpSpPr/>
+        <p:nvPr/>
+      </p:nvGrpSpPr>
+      <p:grpSpPr/>
+      <p:sp>
+        <p:nvSpPr>
+          <p:cNvPr id="2" name="TextBox 1"/>
+          <p:cNvSpPr txBox="1"/>
+          <p:nvPr/>
+        </p:nvSpPr>
+        <p:spPr>
+          <a:xfrm>
+            <a:off x="457200" y="274320"/>
+            <a:ext cx="11247120" cy="914400"/>
+          </a:xfrm>
+          <a:prstGeom prst="rect">
+            <a:avLst/>
+          </a:prstGeom>
+          <a:noFill/>
+        </p:spPr>
+        <p:txBody>
+          <a:bodyPr wrap="square">
+            <a:spAutoFit/>
+          </a:bodyPr>
+          <a:lstStyle/>
+          <a:p>
+            <a:pPr>
+              <a:defRPr sz="2800" b="1">
+                <a:solidFill>
+                  <a:srgbClr val="0072B2"/>
+                </a:solidFill>
+              </a:defRPr>
+            </a:pPr>
+            <a:r>
+              <a:t>¿Y si uso un modelo más grande?</a:t>
+            </a:r>
+          </a:p>
+        </p:txBody>
+      </p:sp>
+      <p:pic>
+        <p:nvPicPr>
+          <p:cNvPr id="3" name="Picture 2" descr="checkpoint_comparison.png"/>
+          <p:cNvPicPr>
+            <a:picLocks noChangeAspect="1"/>
+          </p:cNvPicPr>
+          <p:nvPr/>
+        </p:nvPicPr>
+        <p:blipFill>
+          <a:blip r:embed="rId2"/>
+          <a:stretch>
+            <a:fillRect/>
+          </a:stretch>
+        </p:blipFill>
+        <p:spPr>
+          <a:xfrm>
+            <a:off x="2743200" y="1280160"/>
+            <a:ext cx="7640320" cy="4297680"/>
+          </a:xfrm>
+          <a:prstGeom prst="rect">
+            <a:avLst/>
+          </a:prstGeom>
+        </p:spPr>
+      </p:pic>
+      <p:sp>
+        <p:nvSpPr>
+          <p:cNvPr id="4" name="TextBox 3"/>
+          <p:cNvSpPr txBox="1"/>
+          <p:nvPr/>
+        </p:nvSpPr>
+        <p:spPr>
+          <a:xfrm>
+            <a:off x="548640" y="6126480"/>
+            <a:ext cx="11064240" cy="640080"/>
+          </a:xfrm>
+          <a:prstGeom prst="rect">
+            <a:avLst/>
+          </a:prstGeom>
+          <a:noFill/>
+        </p:spPr>
+        <p:txBody>
+          <a:bodyPr wrap="square">
+            <a:spAutoFit/>
+          </a:bodyPr>
+          <a:lstStyle/>
+          <a:p>
+            <a:pPr>
+              <a:defRPr sz="1300">
+                <a:solidFill>
+                  <a:srgbClr val="0072B2"/>
+                </a:solidFill>
+              </a:defRPr>
+            </a:pPr>
+            <a:r>
+              <a:t>Group no mejora monótonamente (0.075/0.072/0.085) y el text baja (0.35→0.30→0.29). Escalar no resuelve la composición.</a:t>
+            </a:r>
+          </a:p>
+        </p:txBody>
+      </p:sp>
+    </p:spTree>
+  </p:cSld>
+  <p:clrMapOvr>
+    <a:masterClrMapping/>
+  </p:clrMapOvr>
+</p:sld>
+</file>
+
+<file path=ppt/slides/slide22.xml><?xml version="1.0" encoding="utf-8"?>
+<p:sld xmlns:a="http://schemas.openxmlformats.org/drawingml/2006/main" xmlns:p="http://schemas.openxmlformats.org/presentationml/2006/main" xmlns:r="http://schemas.openxmlformats.org/officeDocument/2006/relationships">
+  <p:cSld>
+    <p:spTree>
+      <p:nvGrpSpPr>
+        <p:cNvPr id="1" name=""/>
+        <p:cNvGrpSpPr/>
+        <p:nvPr/>
+      </p:nvGrpSpPr>
+      <p:grpSpPr/>
+      <p:sp>
+        <p:nvSpPr>
+          <p:cNvPr id="2" name="TextBox 1"/>
+          <p:cNvSpPr txBox="1"/>
+          <p:nvPr/>
+        </p:nvSpPr>
+        <p:spPr>
+          <a:xfrm>
+            <a:off x="457200" y="274320"/>
+            <a:ext cx="11247120" cy="914400"/>
+          </a:xfrm>
+          <a:prstGeom prst="rect">
+            <a:avLst/>
+          </a:prstGeom>
+          <a:noFill/>
+        </p:spPr>
+        <p:txBody>
+          <a:bodyPr wrap="square">
+            <a:spAutoFit/>
+          </a:bodyPr>
+          <a:lstStyle/>
+          <a:p>
+            <a:pPr>
+              <a:defRPr sz="2800" b="1">
+                <a:solidFill>
+                  <a:srgbClr val="0072B2"/>
+                </a:solidFill>
+              </a:defRPr>
+            </a:pPr>
+            <a:r>
+              <a:t>Casos de error concretos (group = 0)</a:t>
+            </a:r>
+          </a:p>
+        </p:txBody>
+      </p:sp>
+      <p:pic>
+        <p:nvPicPr>
+          <p:cNvPr id="3" name="Picture 2" descr="qualitative_examples.png"/>
+          <p:cNvPicPr>
+            <a:picLocks noChangeAspect="1"/>
+          </p:cNvPicPr>
+          <p:nvPr/>
+        </p:nvPicPr>
+        <p:blipFill>
+          <a:blip r:embed="rId2"/>
+          <a:stretch>
+            <a:fillRect/>
+          </a:stretch>
+        </p:blipFill>
+        <p:spPr>
+          <a:xfrm>
+            <a:off x="3291840" y="1188720"/>
+            <a:ext cx="3494060" cy="4937760"/>
+          </a:xfrm>
+          <a:prstGeom prst="rect">
+            <a:avLst/>
+          </a:prstGeom>
+        </p:spPr>
+      </p:pic>
+    </p:spTree>
+  </p:cSld>
+  <p:clrMapOvr>
+    <a:masterClrMapping/>
+  </p:clrMapOvr>
+</p:sld>
+</file>
+
+<file path=ppt/slides/slide23.xml><?xml version="1.0" encoding="utf-8"?>
+<p:sld xmlns:a="http://schemas.openxmlformats.org/drawingml/2006/main" xmlns:p="http://schemas.openxmlformats.org/presentationml/2006/main" xmlns:r="http://schemas.openxmlformats.org/officeDocument/2006/relationships">
+  <p:cSld>
+    <p:spTree>
+      <p:nvGrpSpPr>
+        <p:cNvPr id="1" name=""/>
+        <p:cNvGrpSpPr/>
+        <p:nvPr/>
+      </p:nvGrpSpPr>
+      <p:grpSpPr/>
+      <p:sp>
+        <p:nvSpPr>
+          <p:cNvPr id="2" name="TextBox 1"/>
+          <p:cNvSpPr txBox="1"/>
+          <p:nvPr/>
+        </p:nvSpPr>
+        <p:spPr>
+          <a:xfrm>
+            <a:off x="731520" y="2743200"/>
+            <a:ext cx="10698480" cy="1371600"/>
+          </a:xfrm>
+          <a:prstGeom prst="rect">
+            <a:avLst/>
+          </a:prstGeom>
+          <a:noFill/>
+        </p:spPr>
+        <p:txBody>
+          <a:bodyPr wrap="none">
+            <a:spAutoFit/>
+          </a:bodyPr>
+          <a:lstStyle/>
+          <a:p>
+            <a:pPr>
+              <a:defRPr sz="3400" b="1">
+                <a:solidFill>
+                  <a:srgbClr val="0072B2"/>
+                </a:solidFill>
+              </a:defRPr>
+            </a:pPr>
+            <a:r>
+              <a:t>4 · Cierre</a:t>
+            </a:r>
+          </a:p>
+        </p:txBody>
+      </p:sp>
+    </p:spTree>
+  </p:cSld>
+  <p:clrMapOvr>
+    <a:masterClrMapping/>
+  </p:clrMapOvr>
+</p:sld>
+</file>
+
+<file path=ppt/slides/slide24.xml><?xml version="1.0" encoding="utf-8"?>
+<p:sld xmlns:a="http://schemas.openxmlformats.org/drawingml/2006/main" xmlns:p="http://schemas.openxmlformats.org/presentationml/2006/main" xmlns:r="http://schemas.openxmlformats.org/officeDocument/2006/relationships">
+  <p:cSld>
+    <p:spTree>
+      <p:nvGrpSpPr>
+        <p:cNvPr id="1" name=""/>
+        <p:cNvGrpSpPr/>
+        <p:nvPr/>
+      </p:nvGrpSpPr>
+      <p:grpSpPr/>
+      <p:sp>
+        <p:nvSpPr>
+          <p:cNvPr id="2" name="TextBox 1"/>
+          <p:cNvSpPr txBox="1"/>
+          <p:nvPr/>
+        </p:nvSpPr>
+        <p:spPr>
+          <a:xfrm>
+            <a:off x="457200" y="274320"/>
+            <a:ext cx="11247120" cy="914400"/>
+          </a:xfrm>
+          <a:prstGeom prst="rect">
+            <a:avLst/>
+          </a:prstGeom>
+          <a:noFill/>
+        </p:spPr>
+        <p:txBody>
+          <a:bodyPr wrap="square">
+            <a:spAutoFit/>
+          </a:bodyPr>
+          <a:lstStyle/>
+          <a:p>
+            <a:pPr>
+              <a:defRPr sz="2800" b="1">
+                <a:solidFill>
+                  <a:srgbClr val="0072B2"/>
+                </a:solidFill>
+              </a:defRPr>
+            </a:pPr>
+            <a:r>
+              <a:t>Reproducibilidad (lo que pide el examen)</a:t>
+            </a:r>
+          </a:p>
+        </p:txBody>
+      </p:sp>
+      <p:sp>
+        <p:nvSpPr>
+          <p:cNvPr id="3" name="TextBox 2"/>
+          <p:cNvSpPr txBox="1"/>
+          <p:nvPr/>
+        </p:nvSpPr>
+        <p:spPr>
+          <a:xfrm>
+            <a:off x="548640" y="1280160"/>
+            <a:ext cx="11064240" cy="5120640"/>
+          </a:xfrm>
+          <a:prstGeom prst="rect">
+            <a:avLst/>
+          </a:prstGeom>
+          <a:noFill/>
+        </p:spPr>
+        <p:txBody>
+          <a:bodyPr wrap="square">
+            <a:spAutoFit/>
+          </a:bodyPr>
+          <a:lstStyle/>
+          <a:p>
+            <a:pPr>
+              <a:spcAft>
+                <a:spcPts val="700"/>
+              </a:spcAft>
+              <a:defRPr sz="1800">
+                <a:solidFill>
+                  <a:srgbClr val="333333"/>
+                </a:solidFill>
+              </a:defRPr>
+            </a:pPr>
+            <a:r>
+              <a:t>•  Entorno fijo: uv + uv.lock, Python 3.12. Imagen Docker CPU; Makefile.</a:t>
+            </a:r>
+          </a:p>
+          <a:p>
+            <a:pPr>
+              <a:spcAft>
+                <a:spcPts val="700"/>
+              </a:spcAft>
+              <a:defRPr sz="1800">
+                <a:solidFill>
+                  <a:srgbClr val="333333"/>
+                </a:solidFill>
+              </a:defRPr>
+            </a:pPr>
+            <a:r>
+              <a:t>•  Semillas globales; env_logging (hoja de trazabilidad).</a:t>
+            </a:r>
+          </a:p>
+          <a:p>
+            <a:pPr>
+              <a:spcAft>
+                <a:spcPts val="700"/>
+              </a:spcAft>
+              <a:defRPr sz="1800">
+                <a:solidFill>
+                  <a:srgbClr val="333333"/>
+                </a:solidFill>
+              </a:defRPr>
+            </a:pPr>
+            <a:r>
+              <a:t>•  16 tests (pytest) + validación contra clip.jsonl.</a:t>
+            </a:r>
+          </a:p>
+          <a:p>
+            <a:pPr>
+              <a:spcAft>
+                <a:spcPts val="700"/>
+              </a:spcAft>
+              <a:defRPr sz="1800">
+                <a:solidFill>
+                  <a:srgbClr val="333333"/>
+                </a:solidFill>
+              </a:defRPr>
+            </a:pPr>
+            <a:r>
+              <a:t>•  CI en GitHub Actions (push + nocturno). Evidencia commiteada.</a:t>
+            </a:r>
+          </a:p>
+          <a:p>
+            <a:pPr>
+              <a:spcAft>
+                <a:spcPts val="700"/>
+              </a:spcAft>
+              <a:defRPr sz="1800">
+                <a:solidFill>
+                  <a:srgbClr val="333333"/>
+                </a:solidFill>
+              </a:defRPr>
+            </a:pPr>
+            <a:r>
+              <a:t>•  Reproducir de cero: make setup &amp;&amp; make all.</a:t>
+            </a:r>
+          </a:p>
+          <a:p>
+            <a:pPr>
+              <a:spcAft>
+                <a:spcPts val="700"/>
+              </a:spcAft>
+              <a:defRPr sz="1800">
+                <a:solidFill>
+                  <a:srgbClr val="333333"/>
+                </a:solidFill>
+              </a:defRPr>
+            </a:pPr>
+            <a:r>
+              <a:t>•  El dataset gated NO se redistribuye (licencia); cae al set curado si no hay acceso.</a:t>
+            </a:r>
+          </a:p>
+        </p:txBody>
+      </p:sp>
+    </p:spTree>
+  </p:cSld>
+  <p:clrMapOvr>
+    <a:masterClrMapping/>
+  </p:clrMapOvr>
+</p:sld>
+</file>
+
+<file path=ppt/slides/slide25.xml><?xml version="1.0" encoding="utf-8"?>
+<p:sld xmlns:a="http://schemas.openxmlformats.org/drawingml/2006/main" xmlns:p="http://schemas.openxmlformats.org/presentationml/2006/main" xmlns:r="http://schemas.openxmlformats.org/officeDocument/2006/relationships">
+  <p:cSld>
+    <p:spTree>
+      <p:nvGrpSpPr>
+        <p:cNvPr id="1" name=""/>
+        <p:cNvGrpSpPr/>
+        <p:nvPr/>
+      </p:nvGrpSpPr>
+      <p:grpSpPr/>
+      <p:sp>
+        <p:nvSpPr>
+          <p:cNvPr id="2" name="TextBox 1"/>
+          <p:cNvSpPr txBox="1"/>
+          <p:nvPr/>
+        </p:nvSpPr>
+        <p:spPr>
+          <a:xfrm>
+            <a:off x="457200" y="274320"/>
+            <a:ext cx="11247120" cy="914400"/>
+          </a:xfrm>
+          <a:prstGeom prst="rect">
+            <a:avLst/>
+          </a:prstGeom>
+          <a:noFill/>
+        </p:spPr>
+        <p:txBody>
+          <a:bodyPr wrap="square">
+            <a:spAutoFit/>
+          </a:bodyPr>
+          <a:lstStyle/>
+          <a:p>
+            <a:pPr>
+              <a:defRPr sz="2800" b="1">
+                <a:solidFill>
+                  <a:srgbClr val="0072B2"/>
+                </a:solidFill>
+              </a:defRPr>
+            </a:pPr>
+            <a:r>
+              <a:t>Verificación en vivo (lo que mostraré)</a:t>
+            </a:r>
+          </a:p>
+        </p:txBody>
+      </p:sp>
+      <p:sp>
+        <p:nvSpPr>
+          <p:cNvPr id="3" name="TextBox 2"/>
+          <p:cNvSpPr txBox="1"/>
+          <p:nvPr/>
+        </p:nvSpPr>
+        <p:spPr>
+          <a:xfrm>
+            <a:off x="548640" y="1280160"/>
+            <a:ext cx="11064240" cy="5120640"/>
+          </a:xfrm>
+          <a:prstGeom prst="rect">
+            <a:avLst/>
+          </a:prstGeom>
+          <a:noFill/>
+        </p:spPr>
+        <p:txBody>
+          <a:bodyPr wrap="square">
+            <a:spAutoFit/>
+          </a:bodyPr>
+          <a:lstStyle/>
+          <a:p>
+            <a:pPr>
+              <a:spcAft>
+                <a:spcPts val="700"/>
+              </a:spcAft>
+              <a:defRPr sz="1800">
+                <a:solidFill>
+                  <a:srgbClr val="333333"/>
+                </a:solidFill>
+              </a:defRPr>
+            </a:pPr>
+            <a:r>
+              <a:t>•  Celda 1 del notebook: hoja de trazabilidad (versiones, git, dispositivo).</a:t>
+            </a:r>
+          </a:p>
+          <a:p>
+            <a:pPr>
+              <a:spcAft>
+                <a:spcPts val="700"/>
+              </a:spcAft>
+              <a:defRPr sz="1800">
+                <a:solidFill>
+                  <a:srgbClr val="333333"/>
+                </a:solidFill>
+              </a:defRPr>
+            </a:pPr>
+            <a:r>
+              <a:t>•  Celda del scorer: imprime la matriz 2×2 y text/image/group de un par.</a:t>
+            </a:r>
+          </a:p>
+          <a:p>
+            <a:pPr>
+              <a:spcAft>
+                <a:spcPts val="700"/>
+              </a:spcAft>
+              <a:defRPr sz="1800">
+                <a:solidFill>
+                  <a:srgbClr val="333333"/>
+                </a:solidFill>
+              </a:defRPr>
+            </a:pPr>
+            <a:r>
+              <a:t>•  scores.json + figura scores_vs_chance.png.</a:t>
+            </a:r>
+          </a:p>
+          <a:p>
+            <a:pPr>
+              <a:spcAft>
+                <a:spcPts val="700"/>
+              </a:spcAft>
+              <a:defRPr sz="1800">
+                <a:solidFill>
+                  <a:srgbClr val="333333"/>
+                </a:solidFill>
+              </a:defRPr>
+            </a:pPr>
+            <a:r>
+              <a:t>•  python scripts/validate_against_official.py → reproduce los scores oficiales.</a:t>
+            </a:r>
+          </a:p>
+          <a:p>
+            <a:pPr>
+              <a:spcAft>
+                <a:spcPts val="700"/>
+              </a:spcAft>
+              <a:defRPr sz="1800">
+                <a:solidFill>
+                  <a:srgbClr val="333333"/>
+                </a:solidFill>
+              </a:defRPr>
+            </a:pPr>
+            <a:r>
+              <a:t>•  Mejora en vivo: cambiar un prompt/consulta o añadir un par y re-ejecutar.</a:t>
+            </a:r>
+          </a:p>
+        </p:txBody>
+      </p:sp>
+      <p:sp>
+        <p:nvSpPr>
+          <p:cNvPr id="4" name="TextBox 3"/>
+          <p:cNvSpPr txBox="1"/>
+          <p:nvPr/>
+        </p:nvSpPr>
+        <p:spPr>
+          <a:xfrm>
+            <a:off x="548640" y="6126480"/>
+            <a:ext cx="11064240" cy="640080"/>
+          </a:xfrm>
+          <a:prstGeom prst="rect">
+            <a:avLst/>
+          </a:prstGeom>
+          <a:noFill/>
+        </p:spPr>
+        <p:txBody>
+          <a:bodyPr wrap="square">
+            <a:spAutoFit/>
+          </a:bodyPr>
+          <a:lstStyle/>
+          <a:p>
+            <a:pPr>
+              <a:defRPr sz="1300">
+                <a:solidFill>
+                  <a:srgbClr val="0072B2"/>
+                </a:solidFill>
+              </a:defRPr>
+            </a:pPr>
+            <a:r>
+              <a:t>Lo pesado (make run) va pre-ejecutado; en vivo solo corro lo que tarda segundos.</a:t>
+            </a:r>
+          </a:p>
+        </p:txBody>
+      </p:sp>
+    </p:spTree>
+  </p:cSld>
+  <p:clrMapOvr>
+    <a:masterClrMapping/>
+  </p:clrMapOvr>
+</p:sld>
+</file>
+
+<file path=ppt/slides/slide26.xml><?xml version="1.0" encoding="utf-8"?>
+<p:sld xmlns:a="http://schemas.openxmlformats.org/drawingml/2006/main" xmlns:p="http://schemas.openxmlformats.org/presentationml/2006/main" xmlns:r="http://schemas.openxmlformats.org/officeDocument/2006/relationships">
+  <p:cSld>
+    <p:spTree>
+      <p:nvGrpSpPr>
+        <p:cNvPr id="1" name=""/>
+        <p:cNvGrpSpPr/>
+        <p:nvPr/>
+      </p:nvGrpSpPr>
+      <p:grpSpPr/>
+      <p:sp>
+        <p:nvSpPr>
+          <p:cNvPr id="2" name="TextBox 1"/>
+          <p:cNvSpPr txBox="1"/>
+          <p:nvPr/>
+        </p:nvSpPr>
+        <p:spPr>
+          <a:xfrm>
+            <a:off x="457200" y="274320"/>
+            <a:ext cx="11247120" cy="914400"/>
+          </a:xfrm>
+          <a:prstGeom prst="rect">
+            <a:avLst/>
+          </a:prstGeom>
+          <a:noFill/>
+        </p:spPr>
+        <p:txBody>
+          <a:bodyPr wrap="square">
+            <a:spAutoFit/>
+          </a:bodyPr>
+          <a:lstStyle/>
+          <a:p>
+            <a:pPr>
+              <a:defRPr sz="2800" b="1">
+                <a:solidFill>
+                  <a:srgbClr val="0072B2"/>
+                </a:solidFill>
+              </a:defRPr>
+            </a:pPr>
+            <a:r>
+              <a:t>Defensa crítica: limitaciones</a:t>
+            </a:r>
+          </a:p>
+        </p:txBody>
+      </p:sp>
+      <p:sp>
+        <p:nvSpPr>
+          <p:cNvPr id="3" name="TextBox 2"/>
+          <p:cNvSpPr txBox="1"/>
+          <p:nvPr/>
+        </p:nvSpPr>
+        <p:spPr>
+          <a:xfrm>
+            <a:off x="548640" y="1280160"/>
+            <a:ext cx="11064240" cy="5120640"/>
+          </a:xfrm>
+          <a:prstGeom prst="rect">
+            <a:avLst/>
+          </a:prstGeom>
+          <a:noFill/>
+        </p:spPr>
+        <p:txBody>
+          <a:bodyPr wrap="square">
+            <a:spAutoFit/>
+          </a:bodyPr>
+          <a:lstStyle/>
+          <a:p>
+            <a:pPr>
+              <a:spcAft>
+                <a:spcPts val="700"/>
+              </a:spcAft>
+              <a:defRPr sz="1800">
+                <a:solidFill>
+                  <a:srgbClr val="333333"/>
+                </a:solidFill>
+              </a:defRPr>
+            </a:pPr>
+            <a:r>
+              <a:t>•  El group bajo mezcla fallo composicional con ítems ambiguos/difíciles (Diwan et al.).</a:t>
+            </a:r>
+          </a:p>
+          <a:p>
+            <a:pPr>
+              <a:spcAft>
+                <a:spcPts val="700"/>
+              </a:spcAft>
+              <a:defRPr sz="1800">
+                <a:solidFill>
+                  <a:srgbClr val="333333"/>
+                </a:solidFill>
+              </a:defRPr>
+            </a:pPr>
+            <a:r>
+              <a:t>•  Métricas estrictas: sensibles a empates y a la normalización.</a:t>
+            </a:r>
+          </a:p>
+          <a:p>
+            <a:pPr>
+              <a:spcAft>
+                <a:spcPts val="700"/>
+              </a:spcAft>
+              <a:defRPr sz="1800">
+                <a:solidFill>
+                  <a:srgbClr val="333333"/>
+                </a:solidFill>
+              </a:defRPr>
+            </a:pPr>
+            <a:r>
+              <a:t>•  R@K y accuracy no miden composición: necesarias, no suficientes.</a:t>
+            </a:r>
+          </a:p>
+          <a:p>
+            <a:pPr>
+              <a:spcAft>
+                <a:spcPts val="700"/>
+              </a:spcAft>
+              <a:defRPr sz="1800">
+                <a:solidFill>
+                  <a:srgbClr val="333333"/>
+                </a:solidFill>
+              </a:defRPr>
+            </a:pPr>
+            <a:r>
+              <a:t>•  El set curado offline es un proxy sintético (OOD para CLIP).</a:t>
+            </a:r>
+          </a:p>
+        </p:txBody>
+      </p:sp>
+    </p:spTree>
+  </p:cSld>
+  <p:clrMapOvr>
+    <a:masterClrMapping/>
+  </p:clrMapOvr>
+</p:sld>
+</file>
+
+<file path=ppt/slides/slide27.xml><?xml version="1.0" encoding="utf-8"?>
+<p:sld xmlns:a="http://schemas.openxmlformats.org/drawingml/2006/main" xmlns:p="http://schemas.openxmlformats.org/presentationml/2006/main" xmlns:r="http://schemas.openxmlformats.org/officeDocument/2006/relationships">
+  <p:cSld>
+    <p:spTree>
+      <p:nvGrpSpPr>
+        <p:cNvPr id="1" name=""/>
+        <p:cNvGrpSpPr/>
+        <p:nvPr/>
+      </p:nvGrpSpPr>
+      <p:grpSpPr/>
+      <p:sp>
+        <p:nvSpPr>
+          <p:cNvPr id="2" name="TextBox 1"/>
+          <p:cNvSpPr txBox="1"/>
+          <p:nvPr/>
+        </p:nvSpPr>
+        <p:spPr>
+          <a:xfrm>
+            <a:off x="457200" y="274320"/>
+            <a:ext cx="11247120" cy="914400"/>
+          </a:xfrm>
+          <a:prstGeom prst="rect">
+            <a:avLst/>
+          </a:prstGeom>
+          <a:noFill/>
+        </p:spPr>
+        <p:txBody>
+          <a:bodyPr wrap="square">
+            <a:spAutoFit/>
+          </a:bodyPr>
+          <a:lstStyle/>
+          <a:p>
+            <a:pPr>
+              <a:defRPr sz="2800" b="1">
+                <a:solidFill>
+                  <a:srgbClr val="0072B2"/>
+                </a:solidFill>
+              </a:defRPr>
+            </a:pPr>
+            <a:r>
+              <a:t>Mejora propuesta</a:t>
+            </a:r>
+          </a:p>
+        </p:txBody>
+      </p:sp>
+      <p:sp>
+        <p:nvSpPr>
+          <p:cNvPr id="3" name="TextBox 2"/>
+          <p:cNvSpPr txBox="1"/>
+          <p:nvPr/>
+        </p:nvSpPr>
+        <p:spPr>
+          <a:xfrm>
+            <a:off x="548640" y="1280160"/>
+            <a:ext cx="11064240" cy="5120640"/>
+          </a:xfrm>
+          <a:prstGeom prst="rect">
+            <a:avLst/>
+          </a:prstGeom>
+          <a:noFill/>
+        </p:spPr>
+        <p:txBody>
+          <a:bodyPr wrap="square">
+            <a:spAutoFit/>
+          </a:bodyPr>
+          <a:lstStyle/>
+          <a:p>
+            <a:pPr>
+              <a:spcAft>
+                <a:spcPts val="700"/>
+              </a:spcAft>
+              <a:defRPr sz="1800">
+                <a:solidFill>
+                  <a:srgbClr val="333333"/>
+                </a:solidFill>
+              </a:defRPr>
+            </a:pPr>
+            <a:r>
+              <a:t>•  Evaluar un cross-encoder / fusión profunda (C5) y re-ranking con interacción cruzada (C6).</a:t>
+            </a:r>
+          </a:p>
+          <a:p>
+            <a:pPr>
+              <a:spcAft>
+                <a:spcPts val="700"/>
+              </a:spcAft>
+              <a:defRPr sz="1800">
+                <a:solidFill>
+                  <a:srgbClr val="333333"/>
+                </a:solidFill>
+              </a:defRPr>
+            </a:pPr>
+            <a:r>
+              <a:t>•  Versionar embeddings (DVC) para reproducibilidad total de datos.</a:t>
+            </a:r>
+          </a:p>
+          <a:p>
+            <a:pPr>
+              <a:spcAft>
+                <a:spcPts val="700"/>
+              </a:spcAft>
+              <a:defRPr sz="1800">
+                <a:solidFill>
+                  <a:srgbClr val="333333"/>
+                </a:solidFill>
+              </a:defRPr>
+            </a:pPr>
+            <a:r>
+              <a:t>•  Ampliar a más prompts, checkpoints y prompt ensembles (C10).</a:t>
+            </a:r>
+          </a:p>
+          <a:p>
+            <a:pPr>
+              <a:spcAft>
+                <a:spcPts val="700"/>
+              </a:spcAft>
+              <a:defRPr sz="1800">
+                <a:solidFill>
+                  <a:srgbClr val="333333"/>
+                </a:solidFill>
+              </a:defRPr>
+            </a:pPr>
+            <a:r>
+              <a:t>•  Lo que NO aseguro aún: que un cross-encoder lo resuelva. Es hipótesis, no resultado medido.</a:t>
+            </a:r>
+          </a:p>
+        </p:txBody>
+      </p:sp>
+    </p:spTree>
+  </p:cSld>
+  <p:clrMapOvr>
+    <a:masterClrMapping/>
+  </p:clrMapOvr>
+</p:sld>
+</file>
+
+<file path=ppt/slides/slide28.xml><?xml version="1.0" encoding="utf-8"?>
+<p:sld xmlns:a="http://schemas.openxmlformats.org/drawingml/2006/main" xmlns:p="http://schemas.openxmlformats.org/presentationml/2006/main" xmlns:r="http://schemas.openxmlformats.org/officeDocument/2006/relationships">
+  <p:cSld>
+    <p:spTree>
+      <p:nvGrpSpPr>
+        <p:cNvPr id="1" name=""/>
+        <p:cNvGrpSpPr/>
+        <p:nvPr/>
+      </p:nvGrpSpPr>
+      <p:grpSpPr/>
+      <p:sp>
+        <p:nvSpPr>
+          <p:cNvPr id="2" name="TextBox 1"/>
+          <p:cNvSpPr txBox="1"/>
+          <p:nvPr/>
+        </p:nvSpPr>
+        <p:spPr>
+          <a:xfrm>
+            <a:off x="457200" y="274320"/>
+            <a:ext cx="11247120" cy="914400"/>
+          </a:xfrm>
+          <a:prstGeom prst="rect">
+            <a:avLst/>
+          </a:prstGeom>
+          <a:noFill/>
+        </p:spPr>
+        <p:txBody>
+          <a:bodyPr wrap="square">
+            <a:spAutoFit/>
+          </a:bodyPr>
+          <a:lstStyle/>
+          <a:p>
+            <a:pPr>
+              <a:defRPr sz="2800" b="1">
+                <a:solidFill>
+                  <a:srgbClr val="0072B2"/>
+                </a:solidFill>
+              </a:defRPr>
+            </a:pPr>
+            <a:r>
+              <a:t>Conclusión y conexión con el curso</a:t>
+            </a:r>
+          </a:p>
+        </p:txBody>
+      </p:sp>
+      <p:sp>
+        <p:nvSpPr>
+          <p:cNvPr id="3" name="TextBox 2"/>
+          <p:cNvSpPr txBox="1"/>
+          <p:nvPr/>
+        </p:nvSpPr>
+        <p:spPr>
+          <a:xfrm>
+            <a:off x="548640" y="1280160"/>
+            <a:ext cx="11064240" cy="5120640"/>
+          </a:xfrm>
+          <a:prstGeom prst="rect">
+            <a:avLst/>
+          </a:prstGeom>
+          <a:noFill/>
+        </p:spPr>
+        <p:txBody>
+          <a:bodyPr wrap="square">
+            <a:spAutoFit/>
+          </a:bodyPr>
+          <a:lstStyle/>
+          <a:p>
+            <a:pPr>
+              <a:spcAft>
+                <a:spcPts val="700"/>
+              </a:spcAft>
+              <a:defRPr sz="1800">
+                <a:solidFill>
+                  <a:srgbClr val="333333"/>
+                </a:solidFill>
+              </a:defRPr>
+            </a:pPr>
+            <a:r>
+              <a:t>•  C10: motor OpenCLIP (embeddings, coseno, checkpoints, FAISS).</a:t>
+            </a:r>
+          </a:p>
+          <a:p>
+            <a:pPr>
+              <a:spcAft>
+                <a:spcPts val="700"/>
+              </a:spcAft>
+              <a:defRPr sz="1800">
+                <a:solidFill>
+                  <a:srgbClr val="333333"/>
+                </a:solidFill>
+              </a:defRPr>
+            </a:pPr>
+            <a:r>
+              <a:t>•  C5: dual-encoder vs fusión profunda — por qué falla.</a:t>
+            </a:r>
+          </a:p>
+          <a:p>
+            <a:pPr>
+              <a:spcAft>
+                <a:spcPts val="700"/>
+              </a:spcAft>
+              <a:defRPr sz="1800">
+                <a:solidFill>
+                  <a:srgbClr val="333333"/>
+                </a:solidFill>
+              </a:defRPr>
+            </a:pPr>
+            <a:r>
+              <a:t>•  C8: atención crossmodal / interpretabilidad — la prueba de ceguera.</a:t>
+            </a:r>
+          </a:p>
+          <a:p>
+            <a:pPr>
+              <a:spcAft>
+                <a:spcPts val="700"/>
+              </a:spcAft>
+              <a:defRPr sz="1800">
+                <a:solidFill>
+                  <a:srgbClr val="333333"/>
+                </a:solidFill>
+              </a:defRPr>
+            </a:pPr>
+            <a:r>
+              <a:t>•  El retrieval alto NO implica razonamiento composicional. Lo medí, lo validé y lo expliqué de forma reproducible.</a:t>
+            </a:r>
+          </a:p>
+        </p:txBody>
+      </p:sp>
+    </p:spTree>
+  </p:cSld>
+  <p:clrMapOvr>
+    <a:masterClrMapping/>
+  </p:clrMapOvr>
+</p:sld>
+</file>
+
+<file path=ppt/slides/slide29.xml><?xml version="1.0" encoding="utf-8"?>
+<p:sld xmlns:a="http://schemas.openxmlformats.org/drawingml/2006/main" xmlns:p="http://schemas.openxmlformats.org/presentationml/2006/main" xmlns:r="http://schemas.openxmlformats.org/officeDocument/2006/relationships">
+  <p:cSld>
+    <p:spTree>
+      <p:nvGrpSpPr>
+        <p:cNvPr id="1" name=""/>
+        <p:cNvGrpSpPr/>
+        <p:nvPr/>
+      </p:nvGrpSpPr>
+      <p:grpSpPr/>
+      <p:sp>
+        <p:nvSpPr>
+          <p:cNvPr id="2" name="TextBox 1"/>
+          <p:cNvSpPr txBox="1"/>
+          <p:nvPr/>
+        </p:nvSpPr>
+        <p:spPr>
+          <a:xfrm>
+            <a:off x="731520" y="2011680"/>
+            <a:ext cx="10698480" cy="2743200"/>
+          </a:xfrm>
+          <a:prstGeom prst="rect">
+            <a:avLst/>
+          </a:prstGeom>
+          <a:noFill/>
+        </p:spPr>
+        <p:txBody>
+          <a:bodyPr wrap="square">
+            <a:spAutoFit/>
+          </a:bodyPr>
+          <a:lstStyle/>
+          <a:p>
+            <a:pPr>
+              <a:defRPr sz="4000" b="1">
+                <a:solidFill>
+                  <a:srgbClr val="0072B2"/>
+                </a:solidFill>
+              </a:defRPr>
+            </a:pPr>
+            <a:r>
+              <a:t>Gracias</a:t>
+            </a:r>
+          </a:p>
+          <a:p>
+            <a:pPr>
+              <a:defRPr sz="1800">
+                <a:solidFill>
+                  <a:srgbClr val="333333"/>
+                </a:solidFill>
+              </a:defRPr>
+            </a:pPr>
+            <a:r>
+              <a:t>Niels Victor Pacheco Barrios — Winoground / Evaluating CLIP · C5 · C8 · C10</a:t>
+            </a:r>
+          </a:p>
+          <a:p>
+            <a:pPr>
+              <a:defRPr sz="1800">
+                <a:solidFill>
+                  <a:srgbClr val="333333"/>
+                </a:solidFill>
+              </a:defRPr>
+            </a:pPr>
+            <a:r>
+              <a:t>github.com/nielspac177/Winoground-Evaluating-CLIP-MCC225</a:t>
+            </a:r>
+          </a:p>
+          <a:p>
+            <a:pPr>
+              <a:defRPr sz="1800">
+                <a:solidFill>
+                  <a:srgbClr val="333333"/>
+                </a:solidFill>
+              </a:defRPr>
+            </a:pPr>
+            <a:r>
+              <a:t>¿Preguntas?</a:t>
+            </a:r>
+          </a:p>
+        </p:txBody>
+      </p:sp>
     </p:spTree>
   </p:cSld>
   <p:clrMapOvr>
@@ -3352,8 +5958,8 @@
         </p:nvSpPr>
         <p:spPr>
           <a:xfrm>
-            <a:off x="457200" y="274320"/>
-            <a:ext cx="11247120" cy="914400"/>
+            <a:off x="731520" y="2743200"/>
+            <a:ext cx="10698480" cy="1371600"/>
           </a:xfrm>
           <a:prstGeom prst="rect">
             <a:avLst/>
@@ -3367,127 +5973,14 @@
           <a:lstStyle/>
           <a:p>
             <a:pPr>
-              <a:defRPr sz="3000" b="1">
+              <a:defRPr sz="3400" b="1">
                 <a:solidFill>
                   <a:srgbClr val="0072B2"/>
                 </a:solidFill>
               </a:defRPr>
             </a:pPr>
             <a:r>
-              <a:t>Cómo lo obtuve ejecutando C10 (3 min)</a:t>
-            </a:r>
-          </a:p>
-        </p:txBody>
-      </p:sp>
-      <p:sp>
-        <p:nvSpPr>
-          <p:cNvPr id="3" name="TextBox 2"/>
-          <p:cNvSpPr txBox="1"/>
-          <p:nvPr/>
-        </p:nvSpPr>
-        <p:spPr>
-          <a:xfrm>
-            <a:off x="548640" y="1280160"/>
-            <a:ext cx="10789920" cy="5029200"/>
-          </a:xfrm>
-          <a:prstGeom prst="rect">
-            <a:avLst/>
-          </a:prstGeom>
-          <a:noFill/>
-        </p:spPr>
-        <p:txBody>
-          <a:bodyPr wrap="square">
-            <a:spAutoFit/>
-          </a:bodyPr>
-          <a:lstStyle/>
-          <a:p>
-            <a:pPr>
-              <a:spcAft>
-                <a:spcPts val="800"/>
-              </a:spcAft>
-              <a:defRPr sz="1800">
-                <a:solidFill>
-                  <a:srgbClr val="333333"/>
-                </a:solidFill>
-              </a:defRPr>
-            </a:pPr>
-            <a:r>
-              <a:t>•  Motor OpenCLIP del Cuaderno 10: encode imagen/texto, similitud coseno.</a:t>
-            </a:r>
-          </a:p>
-          <a:p>
-            <a:pPr>
-              <a:spcAft>
-                <a:spcPts val="800"/>
-              </a:spcAft>
-              <a:defRPr sz="1800">
-                <a:solidFill>
-                  <a:srgbClr val="333333"/>
-                </a:solidFill>
-              </a:defRPr>
-            </a:pPr>
-            <a:r>
-              <a:t>•  winoground_data.py: real (HF gated) + fallback curado.</a:t>
-            </a:r>
-          </a:p>
-          <a:p>
-            <a:pPr>
-              <a:spcAft>
-                <a:spcPts val="800"/>
-              </a:spcAft>
-              <a:defRPr sz="1800">
-                <a:solidFill>
-                  <a:srgbClr val="333333"/>
-                </a:solidFill>
-              </a:defRPr>
-            </a:pPr>
-            <a:r>
-              <a:t>•  winoground_eval.py: matriz 2×2 sim[caption,imagen] y los 3 scores.</a:t>
-            </a:r>
-          </a:p>
-          <a:p>
-            <a:pPr>
-              <a:spcAft>
-                <a:spcPts val="800"/>
-              </a:spcAft>
-              <a:defRPr sz="1800">
-                <a:solidFill>
-                  <a:srgbClr val="333333"/>
-                </a:solidFill>
-              </a:defRPr>
-            </a:pPr>
-            <a:r>
-              <a:t>•  02_run_winoground.py: scores + IC bootstrap + by-tag + ceguera + R@K.</a:t>
-            </a:r>
-          </a:p>
-          <a:p>
-            <a:pPr>
-              <a:spcAft>
-                <a:spcPts val="800"/>
-              </a:spcAft>
-              <a:defRPr sz="1800">
-                <a:solidFill>
-                  <a:srgbClr val="333333"/>
-                </a:solidFill>
-              </a:defRPr>
-            </a:pPr>
-            <a:r>
-              <a:t>•  text=1 ⇔ s(c0,i0)&gt;s(c0,i1) y s(c1,i1)&gt;s(c1,i0).</a:t>
-            </a:r>
-          </a:p>
-          <a:p>
-            <a:pPr>
-              <a:spcAft>
-                <a:spcPts val="800"/>
-              </a:spcAft>
-              <a:defRPr sz="1800">
-                <a:solidFill>
-                  <a:srgbClr val="333333"/>
-                </a:solidFill>
-              </a:defRPr>
-            </a:pPr>
-            <a:r>
-              <a:t>•  group = text AND image.</a:t>
+              <a:t>1 · El problema</a:t>
             </a:r>
           </a:p>
         </p:txBody>
@@ -3527,48 +6020,92 @@
           <a:noFill/>
         </p:spPr>
         <p:txBody>
-          <a:bodyPr wrap="none">
+          <a:bodyPr wrap="square">
             <a:spAutoFit/>
           </a:bodyPr>
           <a:lstStyle/>
           <a:p>
             <a:pPr>
-              <a:defRPr sz="3000" b="1">
+              <a:defRPr sz="2800" b="1">
                 <a:solidFill>
                   <a:srgbClr val="0072B2"/>
                 </a:solidFill>
               </a:defRPr>
             </a:pPr>
             <a:r>
-              <a:t>Verificación en vivo: los tres scores (3 min)</a:t>
-            </a:r>
-          </a:p>
-        </p:txBody>
-      </p:sp>
-      <p:pic>
-        <p:nvPicPr>
-          <p:cNvPr id="3" name="Picture 2" descr="scores_vs_chance.png"/>
-          <p:cNvPicPr>
-            <a:picLocks noChangeAspect="1"/>
-          </p:cNvPicPr>
+              <a:t>Mi tema: dos papers que cuestionan a CLIP</a:t>
+            </a:r>
+          </a:p>
+        </p:txBody>
+      </p:sp>
+      <p:sp>
+        <p:nvSpPr>
+          <p:cNvPr id="3" name="TextBox 2"/>
+          <p:cNvSpPr txBox="1"/>
           <p:nvPr/>
-        </p:nvPicPr>
-        <p:blipFill>
-          <a:blip r:embed="rId2"/>
-          <a:stretch>
-            <a:fillRect/>
-          </a:stretch>
-        </p:blipFill>
-        <p:spPr>
-          <a:xfrm>
-            <a:off x="2560320" y="1280160"/>
-            <a:ext cx="7965440" cy="5120640"/>
+        </p:nvSpPr>
+        <p:spPr>
+          <a:xfrm>
+            <a:off x="548640" y="1280160"/>
+            <a:ext cx="11064240" cy="5120640"/>
           </a:xfrm>
           <a:prstGeom prst="rect">
             <a:avLst/>
           </a:prstGeom>
-        </p:spPr>
-      </p:pic>
+          <a:noFill/>
+        </p:spPr>
+        <p:txBody>
+          <a:bodyPr wrap="square">
+            <a:spAutoFit/>
+          </a:bodyPr>
+          <a:lstStyle/>
+          <a:p>
+            <a:pPr>
+              <a:spcAft>
+                <a:spcPts val="700"/>
+              </a:spcAft>
+              <a:defRPr sz="1800">
+                <a:solidFill>
+                  <a:srgbClr val="333333"/>
+                </a:solidFill>
+              </a:defRPr>
+            </a:pPr>
+            <a:r>
+              <a:t>•  Winoground (Thrush et al., 2022): ¿razonan de forma composicional o reconocen objetos sueltos?</a:t>
+            </a:r>
+          </a:p>
+          <a:p>
+            <a:pPr>
+              <a:spcAft>
+                <a:spcPts val="700"/>
+              </a:spcAft>
+              <a:defRPr sz="1800">
+                <a:solidFill>
+                  <a:srgbClr val="333333"/>
+                </a:solidFill>
+              </a:defRPr>
+            </a:pPr>
+            <a:r>
+              <a:t>•  Evaluating CLIP (Agarwal et al., 2021): una accuracy mayor no define un modelo 'mejor' (sesgos de clases/prompts).</a:t>
+            </a:r>
+          </a:p>
+          <a:p>
+            <a:pPr>
+              <a:spcAft>
+                <a:spcPts val="700"/>
+              </a:spcAft>
+              <a:defRPr sz="1800">
+                <a:solidFill>
+                  <a:srgbClr val="333333"/>
+                </a:solidFill>
+              </a:defRPr>
+            </a:pPr>
+            <a:r>
+              <a:t>•  Idea común: una buena métrica puede ocultar que el modelo no entiende.</a:t>
+            </a:r>
+          </a:p>
+        </p:txBody>
+      </p:sp>
     </p:spTree>
   </p:cSld>
   <p:clrMapOvr>
@@ -3604,72 +6141,122 @@
           <a:noFill/>
         </p:spPr>
         <p:txBody>
-          <a:bodyPr wrap="none">
+          <a:bodyPr wrap="square">
             <a:spAutoFit/>
           </a:bodyPr>
           <a:lstStyle/>
           <a:p>
             <a:pPr>
-              <a:defRPr sz="3000" b="1">
+              <a:defRPr sz="2800" b="1">
                 <a:solidFill>
                   <a:srgbClr val="0072B2"/>
                 </a:solidFill>
               </a:defRPr>
             </a:pPr>
             <a:r>
-              <a:t>Mejora en vivo: ¿usa la imagen? y por tag (3 min)</a:t>
-            </a:r>
-          </a:p>
-        </p:txBody>
-      </p:sp>
-      <p:pic>
-        <p:nvPicPr>
-          <p:cNvPr id="3" name="Picture 2" descr="blindness.png"/>
-          <p:cNvPicPr>
-            <a:picLocks noChangeAspect="1"/>
-          </p:cNvPicPr>
+              <a:t>El núcleo de Winoground: el par mínimo</a:t>
+            </a:r>
+          </a:p>
+        </p:txBody>
+      </p:sp>
+      <p:sp>
+        <p:nvSpPr>
+          <p:cNvPr id="3" name="TextBox 2"/>
+          <p:cNvSpPr txBox="1"/>
           <p:nvPr/>
-        </p:nvPicPr>
-        <p:blipFill>
-          <a:blip r:embed="rId2"/>
-          <a:stretch>
-            <a:fillRect/>
-          </a:stretch>
-        </p:blipFill>
-        <p:spPr>
-          <a:xfrm>
-            <a:off x="457200" y="1371600"/>
-            <a:ext cx="6543040" cy="4206240"/>
+        </p:nvSpPr>
+        <p:spPr>
+          <a:xfrm>
+            <a:off x="548640" y="1280160"/>
+            <a:ext cx="11064240" cy="5120640"/>
           </a:xfrm>
           <a:prstGeom prst="rect">
             <a:avLst/>
           </a:prstGeom>
-        </p:spPr>
-      </p:pic>
-      <p:pic>
-        <p:nvPicPr>
-          <p:cNvPr id="4" name="Picture 3" descr="by_tag.png"/>
-          <p:cNvPicPr>
-            <a:picLocks noChangeAspect="1"/>
-          </p:cNvPicPr>
-          <p:nvPr/>
-        </p:nvPicPr>
-        <p:blipFill>
-          <a:blip r:embed="rId3"/>
-          <a:stretch>
-            <a:fillRect/>
-          </a:stretch>
-        </p:blipFill>
-        <p:spPr>
-          <a:xfrm>
-            <a:off x="6309360" y="1371600"/>
-            <a:ext cx="7010400" cy="4206240"/>
-          </a:xfrm>
-          <a:prstGeom prst="rect">
-            <a:avLst/>
-          </a:prstGeom>
-        </p:spPr>
-      </p:pic>
+          <a:noFill/>
+        </p:spPr>
+        <p:txBody>
+          <a:bodyPr wrap="square">
+            <a:spAutoFit/>
+          </a:bodyPr>
+          <a:lstStyle/>
+          <a:p>
+            <a:pPr>
+              <a:spcAft>
+                <a:spcPts val="700"/>
+              </a:spcAft>
+              <a:defRPr sz="1800">
+                <a:solidFill>
+                  <a:srgbClr val="333333"/>
+                </a:solidFill>
+              </a:defRPr>
+            </a:pPr>
+            <a:r>
+              <a:t>•  Dos imágenes y dos captions con las MISMAS palabras en distinto orden.</a:t>
+            </a:r>
+          </a:p>
+          <a:p>
+            <a:pPr>
+              <a:spcAft>
+                <a:spcPts val="700"/>
+              </a:spcAft>
+              <a:defRPr sz="1800">
+                <a:solidFill>
+                  <a:srgbClr val="333333"/>
+                </a:solidFill>
+              </a:defRPr>
+            </a:pPr>
+            <a:r>
+              <a:t>•  Caption 0: 'an old person kisses a young person'.</a:t>
+            </a:r>
+          </a:p>
+          <a:p>
+            <a:pPr>
+              <a:spcAft>
+                <a:spcPts val="700"/>
+              </a:spcAft>
+              <a:defRPr sz="1800">
+                <a:solidFill>
+                  <a:srgbClr val="333333"/>
+                </a:solidFill>
+              </a:defRPr>
+            </a:pPr>
+            <a:r>
+              <a:t>•  Caption 1: 'a young person kisses an old person'.</a:t>
+            </a:r>
+          </a:p>
+          <a:p>
+            <a:pPr>
+              <a:spcAft>
+                <a:spcPts val="700"/>
+              </a:spcAft>
+              <a:defRPr sz="1800">
+                <a:solidFill>
+                  <a:srgbClr val="333333"/>
+                </a:solidFill>
+              </a:defRPr>
+            </a:pPr>
+            <a:r>
+              <a:t>•  Distinguirlas exige saber quién hace qué a quién: composición, no reconocimiento.</a:t>
+            </a:r>
+          </a:p>
+          <a:p>
+            <a:pPr>
+              <a:spcAft>
+                <a:spcPts val="700"/>
+              </a:spcAft>
+              <a:defRPr sz="1800">
+                <a:solidFill>
+                  <a:srgbClr val="333333"/>
+                </a:solidFill>
+              </a:defRPr>
+            </a:pPr>
+            <a:r>
+              <a:t>•  400 ejemplos, etiquetados: Object, Relation, Both.</a:t>
+            </a:r>
+          </a:p>
+        </p:txBody>
+      </p:sp>
     </p:spTree>
   </p:cSld>
   <p:clrMapOvr>
@@ -3705,20 +6292,20 @@
           <a:noFill/>
         </p:spPr>
         <p:txBody>
-          <a:bodyPr wrap="none">
+          <a:bodyPr wrap="square">
             <a:spAutoFit/>
           </a:bodyPr>
           <a:lstStyle/>
           <a:p>
             <a:pPr>
-              <a:defRPr sz="3000" b="1">
+              <a:defRPr sz="2800" b="1">
                 <a:solidFill>
                   <a:srgbClr val="0072B2"/>
                 </a:solidFill>
               </a:defRPr>
             </a:pPr>
             <a:r>
-              <a:t>Defensa crítica: limitaciones y mejora (2 min)</a:t>
+              <a:t>Las tres métricas oficiales (matriz 2×2 sim[caption, imagen])</a:t>
             </a:r>
           </a:p>
         </p:txBody>
@@ -3732,7 +6319,7 @@
         <p:spPr>
           <a:xfrm>
             <a:off x="548640" y="1280160"/>
-            <a:ext cx="10789920" cy="5029200"/>
+            <a:ext cx="11064240" cy="5120640"/>
           </a:xfrm>
           <a:prstGeom prst="rect">
             <a:avLst/>
@@ -3747,7 +6334,7 @@
           <a:p>
             <a:pPr>
               <a:spcAft>
-                <a:spcPts val="800"/>
+                <a:spcPts val="700"/>
               </a:spcAft>
               <a:defRPr sz="1800">
                 <a:solidFill>
@@ -3756,13 +6343,13 @@
               </a:defRPr>
             </a:pPr>
             <a:r>
-              <a:t>•  El group score mezcla fallo composicional con ítems ambiguos (Diwan et al.).</a:t>
+              <a:t>•  text score: fijada cada imagen, ¿gana el caption correcto?  s00&gt;s10 y s11&gt;s01.</a:t>
             </a:r>
           </a:p>
           <a:p>
             <a:pPr>
               <a:spcAft>
-                <a:spcPts val="800"/>
+                <a:spcPts val="700"/>
               </a:spcAft>
               <a:defRPr sz="1800">
                 <a:solidFill>
@@ -3771,13 +6358,13 @@
               </a:defRPr>
             </a:pPr>
             <a:r>
-              <a:t>•  Set curado = proxy controlado, no el benchmark oficial.</a:t>
+              <a:t>•  image score: fijado cada caption, ¿gana la imagen correcta?  s00&gt;s01 y s11&gt;s10.</a:t>
             </a:r>
           </a:p>
           <a:p>
             <a:pPr>
               <a:spcAft>
-                <a:spcPts val="800"/>
+                <a:spcPts val="700"/>
               </a:spcAft>
               <a:defRPr sz="1800">
                 <a:solidFill>
@@ -3786,37 +6373,42 @@
               </a:defRPr>
             </a:pPr>
             <a:r>
-              <a:t>•  Azar del group = 1/6 (no 1/16): text e image no son independientes.</a:t>
-            </a:r>
-          </a:p>
-          <a:p>
-            <a:pPr>
-              <a:spcAft>
-                <a:spcPts val="800"/>
-              </a:spcAft>
-              <a:defRPr sz="1800">
-                <a:solidFill>
-                  <a:srgbClr val="333333"/>
-                </a:solidFill>
-              </a:defRPr>
-            </a:pPr>
-            <a:r>
-              <a:t>•  Sensibilidad a empates y a la normalización de embeddings.</a:t>
-            </a:r>
-          </a:p>
-          <a:p>
-            <a:pPr>
-              <a:spcAft>
-                <a:spcPts val="800"/>
-              </a:spcAft>
-              <a:defRPr sz="1800">
-                <a:solidFill>
-                  <a:srgbClr val="333333"/>
-                </a:solidFill>
-              </a:defRPr>
-            </a:pPr>
-            <a:r>
-              <a:t>•  Mejora: evaluar cross-encoder / fusión profunda (C5) y re-ranking (C6); versionar embeddings (DVC).</a:t>
+              <a:t>•  group score: ambas a la vez (text Y image).</a:t>
+            </a:r>
+          </a:p>
+        </p:txBody>
+      </p:sp>
+      <p:sp>
+        <p:nvSpPr>
+          <p:cNvPr id="4" name="TextBox 3"/>
+          <p:cNvSpPr txBox="1"/>
+          <p:nvPr/>
+        </p:nvSpPr>
+        <p:spPr>
+          <a:xfrm>
+            <a:off x="548640" y="6126480"/>
+            <a:ext cx="11064240" cy="640080"/>
+          </a:xfrm>
+          <a:prstGeom prst="rect">
+            <a:avLst/>
+          </a:prstGeom>
+          <a:noFill/>
+        </p:spPr>
+        <p:txBody>
+          <a:bodyPr wrap="square">
+            <a:spAutoFit/>
+          </a:bodyPr>
+          <a:lstStyle/>
+          <a:p>
+            <a:pPr>
+              <a:defRPr sz="1300">
+                <a:solidFill>
+                  <a:srgbClr val="0072B2"/>
+                </a:solidFill>
+              </a:defRPr>
+            </a:pPr>
+            <a:r>
+              <a:t>La diagonal (s00, s11) es el emparejamiento correcto.</a:t>
             </a:r>
           </a:p>
         </p:txBody>
@@ -3856,48 +6448,107 @@
           <a:noFill/>
         </p:spPr>
         <p:txBody>
-          <a:bodyPr wrap="none">
+          <a:bodyPr wrap="square">
             <a:spAutoFit/>
           </a:bodyPr>
           <a:lstStyle/>
           <a:p>
             <a:pPr>
-              <a:defRPr sz="3000" b="1">
+              <a:defRPr sz="2800" b="1">
                 <a:solidFill>
                   <a:srgbClr val="0072B2"/>
                 </a:solidFill>
               </a:defRPr>
             </a:pPr>
             <a:r>
-              <a:t>Backup: comparación de checkpoints</a:t>
-            </a:r>
-          </a:p>
-        </p:txBody>
-      </p:sp>
-      <p:pic>
-        <p:nvPicPr>
-          <p:cNvPr id="3" name="Picture 2" descr="checkpoint_comparison.png"/>
-          <p:cNvPicPr>
-            <a:picLocks noChangeAspect="1"/>
-          </p:cNvPicPr>
+              <a:t>Detalle fino: el azar del group score es 1/6</a:t>
+            </a:r>
+          </a:p>
+        </p:txBody>
+      </p:sp>
+      <p:sp>
+        <p:nvSpPr>
+          <p:cNvPr id="3" name="TextBox 2"/>
+          <p:cNvSpPr txBox="1"/>
           <p:nvPr/>
-        </p:nvPicPr>
-        <p:blipFill>
-          <a:blip r:embed="rId2"/>
-          <a:stretch>
-            <a:fillRect/>
-          </a:stretch>
-        </p:blipFill>
-        <p:spPr>
-          <a:xfrm>
-            <a:off x="2286000" y="1280160"/>
-            <a:ext cx="9103360" cy="5120640"/>
+        </p:nvSpPr>
+        <p:spPr>
+          <a:xfrm>
+            <a:off x="548640" y="1280160"/>
+            <a:ext cx="11064240" cy="5120640"/>
           </a:xfrm>
           <a:prstGeom prst="rect">
             <a:avLst/>
           </a:prstGeom>
-        </p:spPr>
-      </p:pic>
+          <a:noFill/>
+        </p:spPr>
+        <p:txBody>
+          <a:bodyPr wrap="square">
+            <a:spAutoFit/>
+          </a:bodyPr>
+          <a:lstStyle/>
+          <a:p>
+            <a:pPr>
+              <a:spcAft>
+                <a:spcPts val="700"/>
+              </a:spcAft>
+              <a:defRPr sz="1800">
+                <a:solidFill>
+                  <a:srgbClr val="333333"/>
+                </a:solidFill>
+              </a:defRPr>
+            </a:pPr>
+            <a:r>
+              <a:t>•  text e image NO son independientes: comparten las 4 similitudes.</a:t>
+            </a:r>
+          </a:p>
+          <a:p>
+            <a:pPr>
+              <a:spcAft>
+                <a:spcPts val="700"/>
+              </a:spcAft>
+              <a:defRPr sz="1800">
+                <a:solidFill>
+                  <a:srgbClr val="333333"/>
+                </a:solidFill>
+              </a:defRPr>
+            </a:pPr>
+            <a:r>
+              <a:t>•  group=1 exige que ambas diagonales superen a ambas off-diagonales.</a:t>
+            </a:r>
+          </a:p>
+          <a:p>
+            <a:pPr>
+              <a:spcAft>
+                <a:spcPts val="700"/>
+              </a:spcAft>
+              <a:defRPr sz="1800">
+                <a:solidFill>
+                  <a:srgbClr val="333333"/>
+                </a:solidFill>
+              </a:defRPr>
+            </a:pPr>
+            <a:r>
+              <a:t>•  De las 4!=24 ordenaciones, solo 4 cumplen → 4/24 = 1/6 ≈ 0.167.</a:t>
+            </a:r>
+          </a:p>
+          <a:p>
+            <a:pPr>
+              <a:spcAft>
+                <a:spcPts val="700"/>
+              </a:spcAft>
+              <a:defRPr sz="1800">
+                <a:solidFill>
+                  <a:srgbClr val="333333"/>
+                </a:solidFill>
+              </a:defRPr>
+            </a:pPr>
+            <a:r>
+              <a:t>•  No es 1/16. Comparar contra el baseline correcto es parte de la métrica.</a:t>
+            </a:r>
+          </a:p>
+        </p:txBody>
+      </p:sp>
     </p:spTree>
   </p:cSld>
   <p:clrMapOvr>
@@ -3933,48 +6584,130 @@
           <a:noFill/>
         </p:spPr>
         <p:txBody>
+          <a:bodyPr wrap="square">
+            <a:spAutoFit/>
+          </a:bodyPr>
+          <a:lstStyle/>
+          <a:p>
+            <a:pPr>
+              <a:defRPr sz="2800" b="1">
+                <a:solidFill>
+                  <a:srgbClr val="0072B2"/>
+                </a:solidFill>
+              </a:defRPr>
+            </a:pPr>
+            <a:r>
+              <a:t>La pregunta que respondo</a:t>
+            </a:r>
+          </a:p>
+        </p:txBody>
+      </p:sp>
+      <p:sp>
+        <p:nvSpPr>
+          <p:cNvPr id="3" name="TextBox 2"/>
+          <p:cNvSpPr txBox="1"/>
+          <p:nvPr/>
+        </p:nvSpPr>
+        <p:spPr>
+          <a:xfrm>
+            <a:off x="548640" y="2286000"/>
+            <a:ext cx="11064240" cy="5120640"/>
+          </a:xfrm>
+          <a:prstGeom prst="rect">
+            <a:avLst/>
+          </a:prstGeom>
+          <a:noFill/>
+        </p:spPr>
+        <p:txBody>
+          <a:bodyPr wrap="square">
+            <a:spAutoFit/>
+          </a:bodyPr>
+          <a:lstStyle/>
+          <a:p>
+            <a:pPr>
+              <a:spcAft>
+                <a:spcPts val="700"/>
+              </a:spcAft>
+              <a:defRPr sz="2200">
+                <a:solidFill>
+                  <a:srgbClr val="333333"/>
+                </a:solidFill>
+              </a:defRPr>
+            </a:pPr>
+            <a:r>
+              <a:t>•  ¿Un buen Recall@K (recuperación) implica razonamiento composicional?</a:t>
+            </a:r>
+          </a:p>
+          <a:p>
+            <a:pPr>
+              <a:spcAft>
+                <a:spcPts val="700"/>
+              </a:spcAft>
+              <a:defRPr sz="2200">
+                <a:solidFill>
+                  <a:srgbClr val="333333"/>
+                </a:solidFill>
+              </a:defRPr>
+            </a:pPr>
+            <a:r>
+              <a:t>•  Respuesta: no. El mismo modelo, sobre el mismo conjunto, recupera bien y falla la composición.</a:t>
+            </a:r>
+          </a:p>
+        </p:txBody>
+      </p:sp>
+    </p:spTree>
+  </p:cSld>
+  <p:clrMapOvr>
+    <a:masterClrMapping/>
+  </p:clrMapOvr>
+</p:sld>
+</file>
+
+<file path=ppt/slides/slide9.xml><?xml version="1.0" encoding="utf-8"?>
+<p:sld xmlns:a="http://schemas.openxmlformats.org/drawingml/2006/main" xmlns:p="http://schemas.openxmlformats.org/presentationml/2006/main" xmlns:r="http://schemas.openxmlformats.org/officeDocument/2006/relationships">
+  <p:cSld>
+    <p:spTree>
+      <p:nvGrpSpPr>
+        <p:cNvPr id="1" name=""/>
+        <p:cNvGrpSpPr/>
+        <p:nvPr/>
+      </p:nvGrpSpPr>
+      <p:grpSpPr/>
+      <p:sp>
+        <p:nvSpPr>
+          <p:cNvPr id="2" name="TextBox 1"/>
+          <p:cNvSpPr txBox="1"/>
+          <p:nvPr/>
+        </p:nvSpPr>
+        <p:spPr>
+          <a:xfrm>
+            <a:off x="731520" y="2743200"/>
+            <a:ext cx="10698480" cy="1371600"/>
+          </a:xfrm>
+          <a:prstGeom prst="rect">
+            <a:avLst/>
+          </a:prstGeom>
+          <a:noFill/>
+        </p:spPr>
+        <p:txBody>
           <a:bodyPr wrap="none">
             <a:spAutoFit/>
           </a:bodyPr>
           <a:lstStyle/>
           <a:p>
             <a:pPr>
-              <a:defRPr sz="3000" b="1">
+              <a:defRPr sz="3400" b="1">
                 <a:solidFill>
                   <a:srgbClr val="0072B2"/>
                 </a:solidFill>
               </a:defRPr>
             </a:pPr>
             <a:r>
-              <a:t>Backup: casos de error</a:t>
-            </a:r>
-          </a:p>
-        </p:txBody>
-      </p:sp>
-      <p:pic>
-        <p:nvPicPr>
-          <p:cNvPr id="3" name="Picture 2" descr="qualitative_examples.png"/>
-          <p:cNvPicPr>
-            <a:picLocks noChangeAspect="1"/>
-          </p:cNvPicPr>
-          <p:nvPr/>
-        </p:nvPicPr>
-        <p:blipFill>
-          <a:blip r:embed="rId2"/>
-          <a:stretch>
-            <a:fillRect/>
-          </a:stretch>
-        </p:blipFill>
-        <p:spPr>
-          <a:xfrm>
-            <a:off x="3474720" y="1188720"/>
-            <a:ext cx="3752880" cy="5303520"/>
-          </a:xfrm>
-          <a:prstGeom prst="rect">
-            <a:avLst/>
-          </a:prstGeom>
-        </p:spPr>
-      </p:pic>
+              <a:t>2 · Cómo lo medí (Cuaderno 10)</a:t>
+            </a:r>
+          </a:p>
+        </p:txBody>
+      </p:sp>
     </p:spTree>
   </p:cSld>
   <p:clrMapOvr>

</xml_diff>